<commit_message>
Refine presentation design and defense narrative
</commit_message>
<xml_diff>
--- a/presentation/akim-na-5-chasov.pptx
+++ b/presentation/akim-na-5-chasov.pptx
@@ -2,19 +2,19 @@
 <file path=ppt/presentation.xml><?xml version="1.0" encoding="utf-8"?>
 <p:presentation xmlns:p="http://schemas.openxmlformats.org/presentationml/2006/main">
   <p:sldMasterIdLst>
-    <p:sldMasterId xmlns:r="http://schemas.openxmlformats.org/officeDocument/2006/relationships" id="2147483648" r:id="R52fb53db7da74586"/>
+    <p:sldMasterId xmlns:r="http://schemas.openxmlformats.org/officeDocument/2006/relationships" id="2147483648" r:id="R92991a6a88e34923"/>
   </p:sldMasterIdLst>
   <p:notesMasterIdLst>
-    <p:notesMasterId xmlns:r="http://schemas.openxmlformats.org/officeDocument/2006/relationships" r:id="R739f73d5e8d14487"/>
+    <p:notesMasterId xmlns:r="http://schemas.openxmlformats.org/officeDocument/2006/relationships" r:id="R585f47fbd8694da6"/>
   </p:notesMasterIdLst>
   <p:sldIdLst>
-    <p:sldId xmlns:r="http://schemas.openxmlformats.org/officeDocument/2006/relationships" id="256" r:id="Redb564bf8cdd4485"/>
-    <p:sldId xmlns:r="http://schemas.openxmlformats.org/officeDocument/2006/relationships" id="257" r:id="Rbba5ae2ca53048bb"/>
-    <p:sldId xmlns:r="http://schemas.openxmlformats.org/officeDocument/2006/relationships" id="258" r:id="R29ea80105915430d"/>
-    <p:sldId xmlns:r="http://schemas.openxmlformats.org/officeDocument/2006/relationships" id="259" r:id="R516f69718ad844cf"/>
-    <p:sldId xmlns:r="http://schemas.openxmlformats.org/officeDocument/2006/relationships" id="260" r:id="R84a017b1042d4e76"/>
-    <p:sldId xmlns:r="http://schemas.openxmlformats.org/officeDocument/2006/relationships" id="261" r:id="Rd235ff3120de4bb0"/>
-    <p:sldId xmlns:r="http://schemas.openxmlformats.org/officeDocument/2006/relationships" id="262" r:id="R0cb5e169dad14407"/>
+    <p:sldId xmlns:r="http://schemas.openxmlformats.org/officeDocument/2006/relationships" id="256" r:id="R5d2228c85fdc4f63"/>
+    <p:sldId xmlns:r="http://schemas.openxmlformats.org/officeDocument/2006/relationships" id="257" r:id="R25c95d213e47432c"/>
+    <p:sldId xmlns:r="http://schemas.openxmlformats.org/officeDocument/2006/relationships" id="258" r:id="Reb3be86c04c04ed0"/>
+    <p:sldId xmlns:r="http://schemas.openxmlformats.org/officeDocument/2006/relationships" id="259" r:id="R233260238dea4f52"/>
+    <p:sldId xmlns:r="http://schemas.openxmlformats.org/officeDocument/2006/relationships" id="260" r:id="Rbbca287896f04548"/>
+    <p:sldId xmlns:r="http://schemas.openxmlformats.org/officeDocument/2006/relationships" id="261" r:id="R76e3a99412dd4629"/>
+    <p:sldId xmlns:r="http://schemas.openxmlformats.org/officeDocument/2006/relationships" id="262" r:id="Rd7e089d4ae444a3d"/>
   </p:sldIdLst>
   <p:sldSz cx="12192000" cy="6858000"/>
   <p:notesSz cx="6858000" cy="9144000"/>
@@ -448,7 +448,7 @@
           <a:lstStyle xmlns:a="http://schemas.openxmlformats.org/drawingml/2006/main"/>
           <a:p xmlns:a="http://schemas.openxmlformats.org/drawingml/2006/main">
             <a:r>
-              <a:t>15 секунд. «Аким на 5 часов» помогает сравнить последствия пяти городских решений при ограниченном бюджете. Покажем работающий учебный симулятор и пример, где одна смена района меняет результат.</a:t>
+              <a:t>15 секунд. «Аким на 5 часов» помогает сравнить последствия пяти городских решений при ограниченном бюджете. Это учебный симулятор на синтетических данных.</a:t>
             </a:r>
           </a:p>
           <a:p xmlns:a="http://schemas.openxmlformats.org/drawingml/2006/main">
@@ -533,7 +533,7 @@
           <a:lstStyle xmlns:a="http://schemas.openxmlformats.org/drawingml/2006/main"/>
           <a:p xmlns:a="http://schemas.openxmlformats.org/drawingml/2006/main">
             <a:r>
-              <a:t>15 секунд. Есть пять районов с разными исходными показателями. Из четырнадцати мер нужно выбрать ровно пять. Бюджет ограничен ста условными единицами. Модель учитывает сроки внедрения, несовместимости и синергии. Данные организаторов синтетические.</a:t>
+              <a:t>15 секунд. Пять районов с разными исходными показателями. Из четырнадцати мер выбираем ровно пять. Бюджет сто условных единиц, не более двух мер одного направления. Горизонт восемь кварталов. Данные синтетические.</a:t>
             </a:r>
           </a:p>
           <a:p xmlns:a="http://schemas.openxmlformats.org/drawingml/2006/main">
@@ -618,7 +618,7 @@
           <a:lstStyle xmlns:a="http://schemas.openxmlformats.org/drawingml/2006/main"/>
           <a:p xmlns:a="http://schemas.openxmlformats.org/drawingml/2006/main">
             <a:r>
-              <a:t>20 секунд. Пользователь изучает карту и паспорт района, выбирает меры и место реализации. Бюджет виден во время выбора. После расчёта он видит показатели до и после и сохраняет сценарий A для сравнения с текущим B. Карта взята из самого приложения. Географический ориентир: https://www.gov.kz/memleket/entities/astana-nura/press/news/details/560659?lang=ru . Контуры обобщены, административная точность не заявляется.</a:t>
+              <a:t>20 секунд. Карта и паспорт района показывают исходные показатели. Затем выбираем меры и район реализации, видим остаток бюджета. После расчёта сравниваем изменения. В браузере сохраняется вариант A, текущий B используется для сравнения. Карта взята из приложения, контуры обобщены. Географический ориентир: https://www.gov.kz/memleket/entities/astana-nura/press/news/details/560659?lang=ru .</a:t>
             </a:r>
           </a:p>
           <a:p xmlns:a="http://schemas.openxmlformats.org/drawingml/2006/main">
@@ -703,7 +703,7 @@
           <a:lstStyle xmlns:a="http://schemas.openxmlformats.org/drawingml/2006/main"/>
           <a:p xmlns:a="http://schemas.openxmlformats.org/drawingml/2006/main">
             <a:r>
-              <a:t>20 секунд. Python сначала проверяет ограничения и вычисляет результат из JSON. Модель учитывает восемь кварталов, лаги, синергии и порог критичности ниже сорока. По отдельной кнопке настоящий запрос в OpenAI объясняет уже рассчитанный сценарий. AI не создаёт числовые результаты и не изменяет Score. AI требует интернет и конфигурацию команды. Источники реализации: simulator.py, ai_analysis.py, README.md.</a:t>
+              <a:t>20 секунд. Python проверяет ограничения и вычисляет числа из JSON: восемь кварталов, лаги, синергии и порог критичности ниже сорока. По отдельной кнопке настоящий запрос в OpenAI объясняет готовый результат. AI не создаёт числа и не изменяет Score. Для AI нужны сеть и конфигурация команды. Источники: simulator.py, ai_analysis.py, README.md.</a:t>
             </a:r>
           </a:p>
           <a:p xmlns:a="http://schemas.openxmlformats.org/drawingml/2006/main">
@@ -788,7 +788,7 @@
           <a:lstStyle xmlns:a="http://schemas.openxmlformats.org/drawingml/2006/main"/>
           <a:p xmlns:a="http://schemas.openxmlformats.org/drawingml/2006/main">
             <a:r>
-              <a:t>25 секунд. Сценарий A повторяет пример организаторов: M7, M8 и M10 в Нуре, M12 по городу и M5 в Сарыарке. В B только школу и детсад M7 переносим из Нуры в Есиль. Расходы равны 95, но Score A 56,54307, B 55,29777. В A нет критических показателей, в B остаётся один. По сравнению с A оценка Есиля в B больше на 1,10, Нуры меньше на 1,10. A лучше только в этом сравнении, глобальный оптимум не заявляем. Числа получены из simulator.py.</a:t>
+              <a:t>25 секунд. A повторяет пример организаторов: M7, M8 и M10 в Нуре, M12 по городу, M5 в Сарыарке. В B только M7 переносим в Есиль. Расходы одинаковы, 95. Точный Score A 56,54307, B 55,29777. Разница минус 1,24530. В A ноль критических показателей, в B один. В B относительно A Есиль получает +1,10 к оценке, Нура −1,10. Это конкретное сравнение, глобальный оптимум не заявляем.</a:t>
             </a:r>
           </a:p>
           <a:p xmlns:a="http://schemas.openxmlformats.org/drawingml/2006/main">
@@ -873,7 +873,7 @@
           <a:lstStyle xmlns:a="http://schemas.openxmlformats.org/drawingml/2006/main"/>
           <a:p xmlns:a="http://schemas.openxmlformats.org/drawingml/2006/main">
             <a:r>
-              <a:t>15 секунд. Числовая модель работает локально на стандартной библиотеке Python. 28 автоматических тестов покрывают математику, HTTP и AI-контракт. Команда отдельно проверила настоящий API-запрос 23 сентября. Сценарий A сохраняется в браузере. Разработка выполнена с существенной помощью OpenAI Codex. Источники: README.md, tests/, docs/THIRD_PARTY.md.</a:t>
+              <a:t>15 секунд. Числовая модель работает локально на стандартной библиотеке Python. 28 автоматических тестов проходят. Настоящий OpenAI запрос отдельно проверен 23 сентября. Есть сохранение A, сравнение с текущим B и скачивание отчёта с полученным AI-анализом. Разработка выполнена с существенной помощью OpenAI Codex. Источники: README.md, tests/, docs/THIRD_PARTY.md.</a:t>
             </a:r>
           </a:p>
           <a:p xmlns:a="http://schemas.openxmlformats.org/drawingml/2006/main">
@@ -958,7 +958,7 @@
           <a:lstStyle xmlns:a="http://schemas.openxmlformats.org/drawingml/2006/main"/>
           <a:p xmlns:a="http://schemas.openxmlformats.org/drawingml/2006/main">
             <a:r>
-              <a:t>10 секунд. Демонстрация: загрузить пример, рассчитать, сохранить A, перенести M7 в Есиль, рассчитать текущий B и сравнить с A. Затем получить AI-анализ и скачать отчёт. Ограничения: синтетические данные, отсутствие глобального поиска оптимума и случайных событий, локальный сервер. Следующий шаг: подтвердить трактовку направлений у организаторов и проверить модель на реальных данных с экспертами.</a:t>
+              <a:t>10 секунд. Демо: загрузить пример, рассчитать и сохранить A. Перенести M7 в Есиль, рассчитать текущий B и сравнить с A. Получить AI-анализ и скачать отчёт. Данные синтетические, реальная модель требует калибровки. Нет глобального поиска оптимума и случайных событий. Сервер локальный. Следующие шаги: подтвердить трактовку направлений у организаторов и проверить модель с экспертами.</a:t>
             </a:r>
           </a:p>
           <a:p xmlns:a="http://schemas.openxmlformats.org/drawingml/2006/main">
@@ -1041,7 +1041,7 @@
   </p:cSld>
   <p:clrMap bg1="lt1" tx1="dk1" bg2="lt2" tx2="dk2" accent1="accent1" accent2="accent2" accent3="accent3" accent4="accent4" accent5="accent5" accent6="accent6" hlink="hlink" folHlink="folHlink"/>
   <p:sldLayoutIdLst>
-    <p:sldLayoutId xmlns:r="http://schemas.openxmlformats.org/officeDocument/2006/relationships" id="2147483649" r:id="R0bc1e7f718154d66"/>
+    <p:sldLayoutId xmlns:r="http://schemas.openxmlformats.org/officeDocument/2006/relationships" id="2147483649" r:id="Rceb72a2123934572"/>
   </p:sldLayoutIdLst>
   <p:txStyles>
     <p:titleStyle>
@@ -1574,7 +1574,7 @@
     <p:bg>
       <p:bgPr>
         <a:solidFill xmlns:a="http://schemas.openxmlformats.org/drawingml/2006/main">
-          <a:srgbClr val="F5F2E8"/>
+          <a:srgbClr val="194E42"/>
         </a:solidFill>
       </p:bgPr>
     </p:bg>
@@ -1589,20 +1589,20 @@
       </p:grpSpPr>
       <p:pic>
         <p:nvPicPr>
-          <p:cNvPr id="6" name=""/>
+          <p:cNvPr id="5" name=""/>
           <p:cNvPicPr>
             <a:picLocks xmlns:a="http://schemas.openxmlformats.org/drawingml/2006/main" noChangeAspect="1"/>
           </p:cNvPicPr>
           <p:nvPr/>
         </p:nvPicPr>
         <p:blipFill>
-          <a:blip xmlns:r="http://schemas.openxmlformats.org/officeDocument/2006/relationships" xmlns:a="http://schemas.openxmlformats.org/drawingml/2006/main" r:embed="R46d2d22e1a8949d8"/>
+          <a:blip xmlns:r="http://schemas.openxmlformats.org/officeDocument/2006/relationships" xmlns:a="http://schemas.openxmlformats.org/drawingml/2006/main" r:embed="R5e3842e539fd49c9"/>
           <a:stretch xmlns:a="http://schemas.openxmlformats.org/drawingml/2006/main"/>
         </p:blipFill>
         <p:spPr>
           <a:xfrm xmlns:a="http://schemas.openxmlformats.org/drawingml/2006/main">
-            <a:off x="685800" y="619125"/>
-            <a:ext cx="914400" cy="914400"/>
+            <a:off x="685800" y="533400"/>
+            <a:ext cx="857250" cy="857250"/>
           </a:xfrm>
           <a:prstGeom xmlns:a="http://schemas.openxmlformats.org/drawingml/2006/main" prst="rect">
             <a:avLst/>
@@ -1614,7 +1614,7 @@
           <p:cNvPr id="2" name="">
             <a:extLst xmlns:a="http://schemas.openxmlformats.org/drawingml/2006/main">
               <a:ext uri="{FF2B5EF4-FFF2-40B4-BE49-F238E27FC236}">
-                <a16:creationId xmlns:a16="http://schemas.microsoft.com/office/drawing/2014/main" id="{501A6725-459D-4E72-B01C-82794418A244}"/>
+                <a16:creationId xmlns:a16="http://schemas.microsoft.com/office/drawing/2014/main" id="{2335020D-03AC-410C-93BF-51F70C41A845}"/>
               </a:ext>
             </a:extLst>
           </p:cNvPr>
@@ -1625,8 +1625,8 @@
         </p:nvSpPr>
         <p:spPr>
           <a:xfrm xmlns:a="http://schemas.openxmlformats.org/drawingml/2006/main">
-            <a:off x="638175" y="2257425"/>
-            <a:ext cx="10572750" cy="1143000"/>
+            <a:off x="685800" y="1905000"/>
+            <a:ext cx="10477500" cy="381000"/>
           </a:xfrm>
           <a:prstGeom xmlns:a="http://schemas.openxmlformats.org/drawingml/2006/main" prst="rect">
             <a:avLst/>
@@ -1643,25 +1643,25 @@
           <a:lstStyle xmlns:a="http://schemas.openxmlformats.org/drawingml/2006/main"/>
           <a:p xmlns:a="http://schemas.openxmlformats.org/drawingml/2006/main">
             <a:pPr>
-              <a:defRPr sz="6450" b="0">
-                <a:solidFill>
-                  <a:srgbClr val="183B36"/>
-                </a:solidFill>
-                <a:latin typeface="Georgia"/>
-                <a:ea typeface="Georgia"/>
-                <a:cs typeface="Georgia"/>
-              </a:defRPr>
-            </a:pPr>
-            <a:r>
-              <a:rPr sz="6450" b="0">
-                <a:solidFill>
-                  <a:srgbClr val="183B36"/>
-                </a:solidFill>
-                <a:latin typeface="Georgia"/>
-                <a:ea typeface="Georgia"/>
-                <a:cs typeface="Georgia"/>
-              </a:rPr>
-              <a:t>Аким на 5 часов</a:t>
+              <a:defRPr sz="1575" b="1">
+                <a:solidFill>
+                  <a:srgbClr val="E8C77C"/>
+                </a:solidFill>
+                <a:latin typeface="Arial"/>
+                <a:ea typeface="Arial"/>
+                <a:cs typeface="Arial"/>
+              </a:defRPr>
+            </a:pPr>
+            <a:r>
+              <a:rPr sz="1575" b="1">
+                <a:solidFill>
+                  <a:srgbClr val="E8C77C"/>
+                </a:solidFill>
+                <a:latin typeface="Arial"/>
+                <a:ea typeface="Arial"/>
+                <a:cs typeface="Arial"/>
+              </a:rPr>
+              <a:t>ЛАБОРАТОРИЯ ГОРОДСКИХ РЕШЕНИЙ</a:t>
             </a:r>
           </a:p>
         </p:txBody>
@@ -1671,7 +1671,7 @@
           <p:cNvPr id="3" name="">
             <a:extLst xmlns:a="http://schemas.openxmlformats.org/drawingml/2006/main">
               <a:ext uri="{FF2B5EF4-FFF2-40B4-BE49-F238E27FC236}">
-                <a16:creationId xmlns:a16="http://schemas.microsoft.com/office/drawing/2014/main" id="{79BABC2F-7621-4E9D-A2E4-5DEC9DB63B66}"/>
+                <a16:creationId xmlns:a16="http://schemas.microsoft.com/office/drawing/2014/main" id="{B6FFFF6F-D634-4D54-8FE2-5343F2150F23}"/>
               </a:ext>
             </a:extLst>
           </p:cNvPr>
@@ -1682,8 +1682,8 @@
         </p:nvSpPr>
         <p:spPr>
           <a:xfrm xmlns:a="http://schemas.openxmlformats.org/drawingml/2006/main">
-            <a:off x="685800" y="3686175"/>
-            <a:ext cx="10001250" cy="619125"/>
+            <a:off x="619125" y="2628900"/>
+            <a:ext cx="10668000" cy="2324100"/>
           </a:xfrm>
           <a:prstGeom xmlns:a="http://schemas.openxmlformats.org/drawingml/2006/main" prst="rect">
             <a:avLst/>
@@ -1700,25 +1700,48 @@
           <a:lstStyle xmlns:a="http://schemas.openxmlformats.org/drawingml/2006/main"/>
           <a:p xmlns:a="http://schemas.openxmlformats.org/drawingml/2006/main">
             <a:pPr>
-              <a:defRPr sz="2625" b="0">
-                <a:solidFill>
-                  <a:srgbClr val="62736B"/>
-                </a:solidFill>
-                <a:latin typeface="Arial"/>
-                <a:ea typeface="Arial"/>
-                <a:cs typeface="Arial"/>
-              </a:defRPr>
-            </a:pPr>
-            <a:r>
-              <a:rPr sz="2625" b="0">
-                <a:solidFill>
-                  <a:srgbClr val="62736B"/>
-                </a:solidFill>
-                <a:latin typeface="Arial"/>
-                <a:ea typeface="Arial"/>
-                <a:cs typeface="Arial"/>
-              </a:rPr>
-              <a:t>Симулятор городских решений</a:t>
+              <a:defRPr sz="7200" b="0">
+                <a:solidFill>
+                  <a:srgbClr val="F5F2E8"/>
+                </a:solidFill>
+                <a:latin typeface="Georgia"/>
+                <a:ea typeface="Georgia"/>
+                <a:cs typeface="Georgia"/>
+              </a:defRPr>
+            </a:pPr>
+            <a:r>
+              <a:rPr sz="7200" b="0">
+                <a:solidFill>
+                  <a:srgbClr val="F5F2E8"/>
+                </a:solidFill>
+                <a:latin typeface="Georgia"/>
+                <a:ea typeface="Georgia"/>
+                <a:cs typeface="Georgia"/>
+              </a:rPr>
+              <a:t>Аким на</a:t>
+            </a:r>
+          </a:p>
+          <a:p xmlns:a="http://schemas.openxmlformats.org/drawingml/2006/main">
+            <a:pPr>
+              <a:defRPr sz="7200" b="0">
+                <a:solidFill>
+                  <a:srgbClr val="F5F2E8"/>
+                </a:solidFill>
+                <a:latin typeface="Georgia"/>
+                <a:ea typeface="Georgia"/>
+                <a:cs typeface="Georgia"/>
+              </a:defRPr>
+            </a:pPr>
+            <a:r>
+              <a:rPr sz="7200" b="0">
+                <a:solidFill>
+                  <a:srgbClr val="F5F2E8"/>
+                </a:solidFill>
+                <a:latin typeface="Georgia"/>
+                <a:ea typeface="Georgia"/>
+                <a:cs typeface="Georgia"/>
+              </a:rPr>
+              <a:t>5 часов</a:t>
             </a:r>
           </a:p>
         </p:txBody>
@@ -1728,7 +1751,7 @@
           <p:cNvPr id="4" name="">
             <a:extLst xmlns:a="http://schemas.openxmlformats.org/drawingml/2006/main">
               <a:ext uri="{FF2B5EF4-FFF2-40B4-BE49-F238E27FC236}">
-                <a16:creationId xmlns:a16="http://schemas.microsoft.com/office/drawing/2014/main" id="{91EA0C75-6833-4294-9E5E-68C1908BA3B4}"/>
+                <a16:creationId xmlns:a16="http://schemas.microsoft.com/office/drawing/2014/main" id="{144F0208-B6D5-4FE1-ABAE-E87464F9DE36}"/>
               </a:ext>
             </a:extLst>
           </p:cNvPr>
@@ -1739,8 +1762,8 @@
         </p:nvSpPr>
         <p:spPr>
           <a:xfrm xmlns:a="http://schemas.openxmlformats.org/drawingml/2006/main">
-            <a:off x="685800" y="5153025"/>
-            <a:ext cx="10382250" cy="628650"/>
+            <a:off x="714375" y="5467350"/>
+            <a:ext cx="10001250" cy="952500"/>
           </a:xfrm>
           <a:prstGeom xmlns:a="http://schemas.openxmlformats.org/drawingml/2006/main" prst="rect">
             <a:avLst/>
@@ -1757,82 +1780,48 @@
           <a:lstStyle xmlns:a="http://schemas.openxmlformats.org/drawingml/2006/main"/>
           <a:p xmlns:a="http://schemas.openxmlformats.org/drawingml/2006/main">
             <a:pPr>
-              <a:defRPr sz="2100" b="0">
-                <a:solidFill>
-                  <a:srgbClr val="183B36"/>
-                </a:solidFill>
-                <a:latin typeface="Arial"/>
-                <a:ea typeface="Arial"/>
-                <a:cs typeface="Arial"/>
-              </a:defRPr>
-            </a:pPr>
-            <a:r>
-              <a:rPr sz="2100" b="0">
-                <a:solidFill>
-                  <a:srgbClr val="183B36"/>
-                </a:solidFill>
-                <a:latin typeface="Arial"/>
-                <a:ea typeface="Arial"/>
-                <a:cs typeface="Arial"/>
-              </a:rPr>
-              <a:t>Пять решений. Бюджет 100. Горизонт 2 года.</a:t>
-            </a:r>
-          </a:p>
-        </p:txBody>
-      </p:sp>
-      <p:sp>
-        <p:nvSpPr>
-          <p:cNvPr id="5" name="">
-            <a:extLst xmlns:a="http://schemas.openxmlformats.org/drawingml/2006/main">
-              <a:ext uri="{FF2B5EF4-FFF2-40B4-BE49-F238E27FC236}">
-                <a16:creationId xmlns:a16="http://schemas.microsoft.com/office/drawing/2014/main" id="{62227635-DF23-4C32-A5A6-D06F9F551986}"/>
-              </a:ext>
-            </a:extLst>
-          </p:cNvPr>
-          <p:cNvSpPr>
-            <a:spLocks xmlns:a="http://schemas.openxmlformats.org/drawingml/2006/main" noGrp="1"/>
-          </p:cNvSpPr>
-          <p:nvPr/>
-        </p:nvSpPr>
-        <p:spPr>
-          <a:xfrm xmlns:a="http://schemas.openxmlformats.org/drawingml/2006/main">
-            <a:off x="685800" y="6143625"/>
-            <a:ext cx="10477500" cy="304800"/>
-          </a:xfrm>
-          <a:prstGeom xmlns:a="http://schemas.openxmlformats.org/drawingml/2006/main" prst="rect">
-            <a:avLst/>
-          </a:prstGeom>
-          <a:noFill xmlns:a="http://schemas.openxmlformats.org/drawingml/2006/main"/>
-          <a:ln xmlns:a="http://schemas.openxmlformats.org/drawingml/2006/main" w="0">
-            <a:noFill/>
-          </a:ln>
-        </p:spPr>
-        <p:txBody>
-          <a:bodyPr xmlns:a="http://schemas.openxmlformats.org/drawingml/2006/main">
-            <a:noAutofit/>
-          </a:bodyPr>
-          <a:lstStyle xmlns:a="http://schemas.openxmlformats.org/drawingml/2006/main"/>
-          <a:p xmlns:a="http://schemas.openxmlformats.org/drawingml/2006/main">
-            <a:pPr>
-              <a:defRPr sz="1425" b="0">
-                <a:solidFill>
-                  <a:srgbClr val="62736B"/>
-                </a:solidFill>
-                <a:latin typeface="Arial"/>
-                <a:ea typeface="Arial"/>
-                <a:cs typeface="Arial"/>
-              </a:defRPr>
-            </a:pPr>
-            <a:r>
-              <a:rPr sz="1425" b="0">
-                <a:solidFill>
-                  <a:srgbClr val="62736B"/>
-                </a:solidFill>
-                <a:latin typeface="Arial"/>
-                <a:ea typeface="Arial"/>
-                <a:cs typeface="Arial"/>
-              </a:rPr>
-              <a:t>Учебная модель Астаны</a:t>
+              <a:defRPr sz="2475" b="0">
+                <a:solidFill>
+                  <a:srgbClr val="F5F2E8"/>
+                </a:solidFill>
+                <a:latin typeface="Arial"/>
+                <a:ea typeface="Arial"/>
+                <a:cs typeface="Arial"/>
+              </a:defRPr>
+            </a:pPr>
+            <a:r>
+              <a:rPr sz="2475" b="0">
+                <a:solidFill>
+                  <a:srgbClr val="F5F2E8"/>
+                </a:solidFill>
+                <a:latin typeface="Arial"/>
+                <a:ea typeface="Arial"/>
+                <a:cs typeface="Arial"/>
+              </a:rPr>
+              <a:t>Пять решений сегодня.</a:t>
+            </a:r>
+          </a:p>
+          <a:p xmlns:a="http://schemas.openxmlformats.org/drawingml/2006/main">
+            <a:pPr>
+              <a:defRPr sz="2475" b="0">
+                <a:solidFill>
+                  <a:srgbClr val="F5F2E8"/>
+                </a:solidFill>
+                <a:latin typeface="Arial"/>
+                <a:ea typeface="Arial"/>
+                <a:cs typeface="Arial"/>
+              </a:defRPr>
+            </a:pPr>
+            <a:r>
+              <a:rPr sz="2475" b="0">
+                <a:solidFill>
+                  <a:srgbClr val="F5F2E8"/>
+                </a:solidFill>
+                <a:latin typeface="Arial"/>
+                <a:ea typeface="Arial"/>
+                <a:cs typeface="Arial"/>
+              </a:rPr>
+              <a:t>Последствия через два года.</a:t>
             </a:r>
           </a:p>
         </p:txBody>
@@ -1840,7 +1829,7 @@
     </p:spTree>
     <p:extLst>
       <p:ext uri="{BB962C8B-B14F-4D97-AF65-F5344CB8AC3E}">
-        <p14:creationId xmlns:p14="http://schemas.microsoft.com/office/powerpoint/2010/main" val="762732815"/>
+        <p14:creationId xmlns:p14="http://schemas.microsoft.com/office/powerpoint/2010/main" val="1157701809"/>
       </p:ext>
     </p:extLst>
   </p:cSld>
@@ -1871,7 +1860,7 @@
           <p:cNvPr id="13" name="">
             <a:extLst xmlns:a="http://schemas.openxmlformats.org/drawingml/2006/main">
               <a:ext uri="{FF2B5EF4-FFF2-40B4-BE49-F238E27FC236}">
-                <a16:creationId xmlns:a16="http://schemas.microsoft.com/office/drawing/2014/main" id="{5628CC54-8A3F-4C65-92A4-351ED8D71B2A}"/>
+                <a16:creationId xmlns:a16="http://schemas.microsoft.com/office/drawing/2014/main" id="{9816233D-470B-4145-8E39-06E53B687587}"/>
               </a:ext>
             </a:extLst>
           </p:cNvPr>
@@ -1918,7 +1907,7 @@
                 <a:ea typeface="Georgia"/>
                 <a:cs typeface="Georgia"/>
               </a:rPr>
-              <a:t>Условия городского решения</a:t>
+              <a:t>Один бюджет, пять районов</a:t>
             </a:r>
           </a:p>
         </p:txBody>
@@ -1928,7 +1917,7 @@
           <p:cNvPr id="2" name="">
             <a:extLst xmlns:a="http://schemas.openxmlformats.org/drawingml/2006/main">
               <a:ext uri="{FF2B5EF4-FFF2-40B4-BE49-F238E27FC236}">
-                <a16:creationId xmlns:a16="http://schemas.microsoft.com/office/drawing/2014/main" id="{FBFDA0F0-8900-4558-B6A3-DEE6F536FDA9}"/>
+                <a16:creationId xmlns:a16="http://schemas.microsoft.com/office/drawing/2014/main" id="{053FC627-D09C-40E9-8B8E-84E40277DA4E}"/>
               </a:ext>
             </a:extLst>
           </p:cNvPr>
@@ -1939,8 +1928,8 @@
         </p:nvSpPr>
         <p:spPr>
           <a:xfrm xmlns:a="http://schemas.openxmlformats.org/drawingml/2006/main">
-            <a:off x="666750" y="1504950"/>
-            <a:ext cx="10668000" cy="619125"/>
+            <a:off x="685800" y="1695450"/>
+            <a:ext cx="6667500" cy="1066800"/>
           </a:xfrm>
           <a:prstGeom xmlns:a="http://schemas.openxmlformats.org/drawingml/2006/main" prst="rect">
             <a:avLst/>
@@ -1957,7 +1946,7 @@
           <a:lstStyle xmlns:a="http://schemas.openxmlformats.org/drawingml/2006/main"/>
           <a:p xmlns:a="http://schemas.openxmlformats.org/drawingml/2006/main">
             <a:pPr>
-              <a:defRPr sz="2325" b="0">
+              <a:defRPr sz="2700" b="0">
                 <a:solidFill>
                   <a:srgbClr val="62736B"/>
                 </a:solidFill>
@@ -1967,7 +1956,7 @@
               </a:defRPr>
             </a:pPr>
             <a:r>
-              <a:rPr sz="2325" b="0">
+              <a:rPr sz="2700" b="0">
                 <a:solidFill>
                   <a:srgbClr val="62736B"/>
                 </a:solidFill>
@@ -1975,7 +1964,30 @@
                 <a:ea typeface="Arial"/>
                 <a:cs typeface="Arial"/>
               </a:rPr>
-              <a:t>У районов разные потребности, а бюджет общий</a:t>
+              <a:t>Потребности районов различаются.</a:t>
+            </a:r>
+          </a:p>
+          <a:p xmlns:a="http://schemas.openxmlformats.org/drawingml/2006/main">
+            <a:pPr>
+              <a:defRPr sz="2700" b="0">
+                <a:solidFill>
+                  <a:srgbClr val="62736B"/>
+                </a:solidFill>
+                <a:latin typeface="Arial"/>
+                <a:ea typeface="Arial"/>
+                <a:cs typeface="Arial"/>
+              </a:defRPr>
+            </a:pPr>
+            <a:r>
+              <a:rPr sz="2700" b="0">
+                <a:solidFill>
+                  <a:srgbClr val="62736B"/>
+                </a:solidFill>
+                <a:latin typeface="Arial"/>
+                <a:ea typeface="Arial"/>
+                <a:cs typeface="Arial"/>
+              </a:rPr>
+              <a:t>Ресурсы города ограничены.</a:t>
             </a:r>
           </a:p>
         </p:txBody>
@@ -1985,7 +1997,7 @@
           <p:cNvPr id="3" name="">
             <a:extLst xmlns:a="http://schemas.openxmlformats.org/drawingml/2006/main">
               <a:ext uri="{FF2B5EF4-FFF2-40B4-BE49-F238E27FC236}">
-                <a16:creationId xmlns:a16="http://schemas.microsoft.com/office/drawing/2014/main" id="{015883AC-2563-4BCF-AA5F-5DB88425DEDD}"/>
+                <a16:creationId xmlns:a16="http://schemas.microsoft.com/office/drawing/2014/main" id="{507307FA-E27D-4F0E-B941-8F315B9F5324}"/>
               </a:ext>
             </a:extLst>
           </p:cNvPr>
@@ -1996,8 +2008,8 @@
         </p:nvSpPr>
         <p:spPr>
           <a:xfrm xmlns:a="http://schemas.openxmlformats.org/drawingml/2006/main">
-            <a:off x="666750" y="2676525"/>
-            <a:ext cx="2095500" cy="809625"/>
+            <a:off x="7867650" y="1828800"/>
+            <a:ext cx="3810000" cy="1743075"/>
           </a:xfrm>
           <a:prstGeom xmlns:a="http://schemas.openxmlformats.org/drawingml/2006/main" prst="rect">
             <a:avLst/>
@@ -2014,7 +2026,7 @@
           <a:lstStyle xmlns:a="http://schemas.openxmlformats.org/drawingml/2006/main"/>
           <a:p xmlns:a="http://schemas.openxmlformats.org/drawingml/2006/main">
             <a:pPr>
-              <a:defRPr sz="5550" b="1">
+              <a:defRPr sz="10650" b="1">
                 <a:solidFill>
                   <a:srgbClr val="194E42"/>
                 </a:solidFill>
@@ -2024,7 +2036,7 @@
               </a:defRPr>
             </a:pPr>
             <a:r>
-              <a:rPr sz="5550" b="1">
+              <a:rPr sz="10650" b="1">
                 <a:solidFill>
                   <a:srgbClr val="194E42"/>
                 </a:solidFill>
@@ -2032,7 +2044,7 @@
                 <a:ea typeface="Arial"/>
                 <a:cs typeface="Arial"/>
               </a:rPr>
-              <a:t>5</a:t>
+              <a:t>100</a:t>
             </a:r>
           </a:p>
         </p:txBody>
@@ -2042,7 +2054,7 @@
           <p:cNvPr id="4" name="">
             <a:extLst xmlns:a="http://schemas.openxmlformats.org/drawingml/2006/main">
               <a:ext uri="{FF2B5EF4-FFF2-40B4-BE49-F238E27FC236}">
-                <a16:creationId xmlns:a16="http://schemas.microsoft.com/office/drawing/2014/main" id="{DA2575BD-19B4-4F95-8E43-6CDE3048FDF4}"/>
+                <a16:creationId xmlns:a16="http://schemas.microsoft.com/office/drawing/2014/main" id="{27B83779-D0CA-4602-8A04-B03175EC297D}"/>
               </a:ext>
             </a:extLst>
           </p:cNvPr>
@@ -2053,8 +2065,8 @@
         </p:nvSpPr>
         <p:spPr>
           <a:xfrm xmlns:a="http://schemas.openxmlformats.org/drawingml/2006/main">
-            <a:off x="666750" y="3629025"/>
-            <a:ext cx="2095500" cy="781050"/>
+            <a:off x="7867650" y="3695700"/>
+            <a:ext cx="3714750" cy="666750"/>
           </a:xfrm>
           <a:prstGeom xmlns:a="http://schemas.openxmlformats.org/drawingml/2006/main" prst="rect">
             <a:avLst/>
@@ -2089,7 +2101,7 @@
                 <a:ea typeface="Arial"/>
                 <a:cs typeface="Arial"/>
               </a:rPr>
-              <a:t>районов</a:t>
+              <a:t>условных единиц бюджета</a:t>
             </a:r>
           </a:p>
         </p:txBody>
@@ -2099,7 +2111,7 @@
           <p:cNvPr id="5" name="">
             <a:extLst xmlns:a="http://schemas.openxmlformats.org/drawingml/2006/main">
               <a:ext uri="{FF2B5EF4-FFF2-40B4-BE49-F238E27FC236}">
-                <a16:creationId xmlns:a16="http://schemas.microsoft.com/office/drawing/2014/main" id="{8848E090-2D44-4D65-A03E-695D6EB7B6AF}"/>
+                <a16:creationId xmlns:a16="http://schemas.microsoft.com/office/drawing/2014/main" id="{83E379DA-010E-4892-B27B-20E42294B048}"/>
               </a:ext>
             </a:extLst>
           </p:cNvPr>
@@ -2110,8 +2122,8 @@
         </p:nvSpPr>
         <p:spPr>
           <a:xfrm xmlns:a="http://schemas.openxmlformats.org/drawingml/2006/main">
-            <a:off x="3238500" y="2676525"/>
-            <a:ext cx="2571750" cy="809625"/>
+            <a:off x="666750" y="3467100"/>
+            <a:ext cx="2190750" cy="1076325"/>
           </a:xfrm>
           <a:prstGeom xmlns:a="http://schemas.openxmlformats.org/drawingml/2006/main" prst="rect">
             <a:avLst/>
@@ -2128,7 +2140,7 @@
           <a:lstStyle xmlns:a="http://schemas.openxmlformats.org/drawingml/2006/main"/>
           <a:p xmlns:a="http://schemas.openxmlformats.org/drawingml/2006/main">
             <a:pPr>
-              <a:defRPr sz="5550" b="1">
+              <a:defRPr sz="6600" b="1">
                 <a:solidFill>
                   <a:srgbClr val="194E42"/>
                 </a:solidFill>
@@ -2138,7 +2150,7 @@
               </a:defRPr>
             </a:pPr>
             <a:r>
-              <a:rPr sz="5550" b="1">
+              <a:rPr sz="6600" b="1">
                 <a:solidFill>
                   <a:srgbClr val="194E42"/>
                 </a:solidFill>
@@ -2146,7 +2158,7 @@
                 <a:ea typeface="Arial"/>
                 <a:cs typeface="Arial"/>
               </a:rPr>
-              <a:t>100</a:t>
+              <a:t>5</a:t>
             </a:r>
           </a:p>
         </p:txBody>
@@ -2156,7 +2168,7 @@
           <p:cNvPr id="6" name="">
             <a:extLst xmlns:a="http://schemas.openxmlformats.org/drawingml/2006/main">
               <a:ext uri="{FF2B5EF4-FFF2-40B4-BE49-F238E27FC236}">
-                <a16:creationId xmlns:a16="http://schemas.microsoft.com/office/drawing/2014/main" id="{CDFDB0D4-D418-45E3-A27F-3DDFF12E0BD5}"/>
+                <a16:creationId xmlns:a16="http://schemas.microsoft.com/office/drawing/2014/main" id="{504874F7-0618-46C8-A2AB-000EB6AC0AF0}"/>
               </a:ext>
             </a:extLst>
           </p:cNvPr>
@@ -2167,8 +2179,8 @@
         </p:nvSpPr>
         <p:spPr>
           <a:xfrm xmlns:a="http://schemas.openxmlformats.org/drawingml/2006/main">
-            <a:off x="3238500" y="3629025"/>
-            <a:ext cx="2571750" cy="781050"/>
+            <a:off x="695325" y="4610100"/>
+            <a:ext cx="2190750" cy="438150"/>
           </a:xfrm>
           <a:prstGeom xmlns:a="http://schemas.openxmlformats.org/drawingml/2006/main" prst="rect">
             <a:avLst/>
@@ -2203,30 +2215,7 @@
                 <a:ea typeface="Arial"/>
                 <a:cs typeface="Arial"/>
               </a:rPr>
-              <a:t>условных единиц</a:t>
-            </a:r>
-          </a:p>
-          <a:p xmlns:a="http://schemas.openxmlformats.org/drawingml/2006/main">
-            <a:pPr>
-              <a:defRPr sz="1875" b="0">
-                <a:solidFill>
-                  <a:srgbClr val="62736B"/>
-                </a:solidFill>
-                <a:latin typeface="Arial"/>
-                <a:ea typeface="Arial"/>
-                <a:cs typeface="Arial"/>
-              </a:defRPr>
-            </a:pPr>
-            <a:r>
-              <a:rPr sz="1875" b="0">
-                <a:solidFill>
-                  <a:srgbClr val="62736B"/>
-                </a:solidFill>
-                <a:latin typeface="Arial"/>
-                <a:ea typeface="Arial"/>
-                <a:cs typeface="Arial"/>
-              </a:rPr>
-              <a:t>бюджета</a:t>
+              <a:t>районов</a:t>
             </a:r>
           </a:p>
         </p:txBody>
@@ -2236,7 +2225,7 @@
           <p:cNvPr id="7" name="">
             <a:extLst xmlns:a="http://schemas.openxmlformats.org/drawingml/2006/main">
               <a:ext uri="{FF2B5EF4-FFF2-40B4-BE49-F238E27FC236}">
-                <a16:creationId xmlns:a16="http://schemas.microsoft.com/office/drawing/2014/main" id="{8FD68CC9-D721-4F75-84DB-B77285CE9EDD}"/>
+                <a16:creationId xmlns:a16="http://schemas.microsoft.com/office/drawing/2014/main" id="{0F4ED237-1D61-4AA8-9CC7-AA340B3D034E}"/>
               </a:ext>
             </a:extLst>
           </p:cNvPr>
@@ -2247,8 +2236,8 @@
         </p:nvSpPr>
         <p:spPr>
           <a:xfrm xmlns:a="http://schemas.openxmlformats.org/drawingml/2006/main">
-            <a:off x="6191250" y="2676525"/>
-            <a:ext cx="2381250" cy="809625"/>
+            <a:off x="3095625" y="3467100"/>
+            <a:ext cx="2190750" cy="1076325"/>
           </a:xfrm>
           <a:prstGeom xmlns:a="http://schemas.openxmlformats.org/drawingml/2006/main" prst="rect">
             <a:avLst/>
@@ -2265,7 +2254,7 @@
           <a:lstStyle xmlns:a="http://schemas.openxmlformats.org/drawingml/2006/main"/>
           <a:p xmlns:a="http://schemas.openxmlformats.org/drawingml/2006/main">
             <a:pPr>
-              <a:defRPr sz="5550" b="1">
+              <a:defRPr sz="6600" b="1">
                 <a:solidFill>
                   <a:srgbClr val="194E42"/>
                 </a:solidFill>
@@ -2275,7 +2264,7 @@
               </a:defRPr>
             </a:pPr>
             <a:r>
-              <a:rPr sz="5550" b="1">
+              <a:rPr sz="6600" b="1">
                 <a:solidFill>
                   <a:srgbClr val="194E42"/>
                 </a:solidFill>
@@ -2293,7 +2282,7 @@
           <p:cNvPr id="8" name="">
             <a:extLst xmlns:a="http://schemas.openxmlformats.org/drawingml/2006/main">
               <a:ext uri="{FF2B5EF4-FFF2-40B4-BE49-F238E27FC236}">
-                <a16:creationId xmlns:a16="http://schemas.microsoft.com/office/drawing/2014/main" id="{8162C83E-CDCC-4D0D-AA73-58E119ECA93F}"/>
+                <a16:creationId xmlns:a16="http://schemas.microsoft.com/office/drawing/2014/main" id="{F9FDD815-09F3-4C4B-A4FC-12A5E98203B4}"/>
               </a:ext>
             </a:extLst>
           </p:cNvPr>
@@ -2304,8 +2293,8 @@
         </p:nvSpPr>
         <p:spPr>
           <a:xfrm xmlns:a="http://schemas.openxmlformats.org/drawingml/2006/main">
-            <a:off x="6191250" y="3629025"/>
-            <a:ext cx="2381250" cy="781050"/>
+            <a:off x="3124200" y="4610100"/>
+            <a:ext cx="2571750" cy="438150"/>
           </a:xfrm>
           <a:prstGeom xmlns:a="http://schemas.openxmlformats.org/drawingml/2006/main" prst="rect">
             <a:avLst/>
@@ -2350,7 +2339,7 @@
           <p:cNvPr id="9" name="">
             <a:extLst xmlns:a="http://schemas.openxmlformats.org/drawingml/2006/main">
               <a:ext uri="{FF2B5EF4-FFF2-40B4-BE49-F238E27FC236}">
-                <a16:creationId xmlns:a16="http://schemas.microsoft.com/office/drawing/2014/main" id="{AF088E89-4660-4E16-B754-41380B1DCCA7}"/>
+                <a16:creationId xmlns:a16="http://schemas.microsoft.com/office/drawing/2014/main" id="{81C15E21-E985-478F-9D23-9ECC73A56036}"/>
               </a:ext>
             </a:extLst>
           </p:cNvPr>
@@ -2361,8 +2350,8 @@
         </p:nvSpPr>
         <p:spPr>
           <a:xfrm xmlns:a="http://schemas.openxmlformats.org/drawingml/2006/main">
-            <a:off x="9144000" y="2676525"/>
-            <a:ext cx="2381250" cy="809625"/>
+            <a:off x="5810250" y="3467100"/>
+            <a:ext cx="1714500" cy="1076325"/>
           </a:xfrm>
           <a:prstGeom xmlns:a="http://schemas.openxmlformats.org/drawingml/2006/main" prst="rect">
             <a:avLst/>
@@ -2379,7 +2368,7 @@
           <a:lstStyle xmlns:a="http://schemas.openxmlformats.org/drawingml/2006/main"/>
           <a:p xmlns:a="http://schemas.openxmlformats.org/drawingml/2006/main">
             <a:pPr>
-              <a:defRPr sz="5550" b="1">
+              <a:defRPr sz="6600" b="1">
                 <a:solidFill>
                   <a:srgbClr val="194E42"/>
                 </a:solidFill>
@@ -2389,7 +2378,7 @@
               </a:defRPr>
             </a:pPr>
             <a:r>
-              <a:rPr sz="5550" b="1">
+              <a:rPr sz="6600" b="1">
                 <a:solidFill>
                   <a:srgbClr val="194E42"/>
                 </a:solidFill>
@@ -2407,7 +2396,7 @@
           <p:cNvPr id="10" name="">
             <a:extLst xmlns:a="http://schemas.openxmlformats.org/drawingml/2006/main">
               <a:ext uri="{FF2B5EF4-FFF2-40B4-BE49-F238E27FC236}">
-                <a16:creationId xmlns:a16="http://schemas.microsoft.com/office/drawing/2014/main" id="{945642E0-AEAD-40A3-BC4A-97B9A6AE0B63}"/>
+                <a16:creationId xmlns:a16="http://schemas.microsoft.com/office/drawing/2014/main" id="{4C20557D-25D6-4546-9F48-6040EDDA85FF}"/>
               </a:ext>
             </a:extLst>
           </p:cNvPr>
@@ -2418,8 +2407,8 @@
         </p:nvSpPr>
         <p:spPr>
           <a:xfrm xmlns:a="http://schemas.openxmlformats.org/drawingml/2006/main">
-            <a:off x="9144000" y="3629025"/>
-            <a:ext cx="2381250" cy="781050"/>
+            <a:off x="5838825" y="4610100"/>
+            <a:ext cx="2095500" cy="438150"/>
           </a:xfrm>
           <a:prstGeom xmlns:a="http://schemas.openxmlformats.org/drawingml/2006/main" prst="rect">
             <a:avLst/>
@@ -2464,7 +2453,7 @@
           <p:cNvPr id="11" name="">
             <a:extLst xmlns:a="http://schemas.openxmlformats.org/drawingml/2006/main">
               <a:ext uri="{FF2B5EF4-FFF2-40B4-BE49-F238E27FC236}">
-                <a16:creationId xmlns:a16="http://schemas.microsoft.com/office/drawing/2014/main" id="{FFAADB39-EB79-45B6-87FA-12E7EB8323F6}"/>
+                <a16:creationId xmlns:a16="http://schemas.microsoft.com/office/drawing/2014/main" id="{83802A05-BEED-45E4-B16A-9AF90CEFBBDF}"/>
               </a:ext>
             </a:extLst>
           </p:cNvPr>
@@ -2475,8 +2464,8 @@
         </p:nvSpPr>
         <p:spPr>
           <a:xfrm xmlns:a="http://schemas.openxmlformats.org/drawingml/2006/main">
-            <a:off x="666750" y="5210175"/>
-            <a:ext cx="10763250" cy="581025"/>
+            <a:off x="685800" y="5572125"/>
+            <a:ext cx="10858500" cy="609600"/>
           </a:xfrm>
           <a:prstGeom xmlns:a="http://schemas.openxmlformats.org/drawingml/2006/main" prst="rect">
             <a:avLst/>
@@ -2493,7 +2482,7 @@
           <a:lstStyle xmlns:a="http://schemas.openxmlformats.org/drawingml/2006/main"/>
           <a:p xmlns:a="http://schemas.openxmlformats.org/drawingml/2006/main">
             <a:pPr>
-              <a:defRPr sz="2250" b="1">
+              <a:defRPr sz="2325" b="1">
                 <a:solidFill>
                   <a:srgbClr val="183B36"/>
                 </a:solidFill>
@@ -2503,7 +2492,7 @@
               </a:defRPr>
             </a:pPr>
             <a:r>
-              <a:rPr sz="2250" b="1">
+              <a:rPr sz="2325" b="1">
                 <a:solidFill>
                   <a:srgbClr val="183B36"/>
                 </a:solidFill>
@@ -2521,7 +2510,7 @@
           <p:cNvPr id="12" name="">
             <a:extLst xmlns:a="http://schemas.openxmlformats.org/drawingml/2006/main">
               <a:ext uri="{FF2B5EF4-FFF2-40B4-BE49-F238E27FC236}">
-                <a16:creationId xmlns:a16="http://schemas.microsoft.com/office/drawing/2014/main" id="{DD7792D8-4171-400A-ACCE-28236BD1040A}"/>
+                <a16:creationId xmlns:a16="http://schemas.microsoft.com/office/drawing/2014/main" id="{933A6DC2-D27D-4618-B17B-99BC01F0BA82}"/>
               </a:ext>
             </a:extLst>
           </p:cNvPr>
@@ -2532,8 +2521,8 @@
         </p:nvSpPr>
         <p:spPr>
           <a:xfrm xmlns:a="http://schemas.openxmlformats.org/drawingml/2006/main">
-            <a:off x="666750" y="6096000"/>
-            <a:ext cx="10858500" cy="342900"/>
+            <a:off x="685800" y="6324600"/>
+            <a:ext cx="10858500" cy="285750"/>
           </a:xfrm>
           <a:prstGeom xmlns:a="http://schemas.openxmlformats.org/drawingml/2006/main" prst="rect">
             <a:avLst/>
@@ -2550,7 +2539,7 @@
           <a:lstStyle xmlns:a="http://schemas.openxmlformats.org/drawingml/2006/main"/>
           <a:p xmlns:a="http://schemas.openxmlformats.org/drawingml/2006/main">
             <a:pPr>
-              <a:defRPr sz="1500" b="0">
+              <a:defRPr sz="1350" b="0">
                 <a:solidFill>
                   <a:srgbClr val="62736B"/>
                 </a:solidFill>
@@ -2560,7 +2549,7 @@
               </a:defRPr>
             </a:pPr>
             <a:r>
-              <a:rPr sz="1500" b="0">
+              <a:rPr sz="1350" b="0">
                 <a:solidFill>
                   <a:srgbClr val="62736B"/>
                 </a:solidFill>
@@ -2568,7 +2557,7 @@
                 <a:ea typeface="Arial"/>
                 <a:cs typeface="Arial"/>
               </a:rPr>
-              <a:t>Синтетические данные организаторов. Результат описывает учебную модель.</a:t>
+              <a:t>Учебная модель на синтетических данных организаторов</a:t>
             </a:r>
           </a:p>
         </p:txBody>
@@ -2576,7 +2565,7 @@
     </p:spTree>
     <p:extLst>
       <p:ext uri="{BB962C8B-B14F-4D97-AF65-F5344CB8AC3E}">
-        <p14:creationId xmlns:p14="http://schemas.microsoft.com/office/powerpoint/2010/main" val="478638023"/>
+        <p14:creationId xmlns:p14="http://schemas.microsoft.com/office/powerpoint/2010/main" val="1236174206"/>
       </p:ext>
     </p:extLst>
   </p:cSld>
@@ -2604,10 +2593,10 @@
       </p:grpSpPr>
       <p:sp>
         <p:nvSpPr>
-          <p:cNvPr id="15" name="">
+          <p:cNvPr id="10" name="">
             <a:extLst xmlns:a="http://schemas.openxmlformats.org/drawingml/2006/main">
               <a:ext uri="{FF2B5EF4-FFF2-40B4-BE49-F238E27FC236}">
-                <a16:creationId xmlns:a16="http://schemas.microsoft.com/office/drawing/2014/main" id="{36BCE73A-A5AE-4C00-9758-AE6F45C70282}"/>
+                <a16:creationId xmlns:a16="http://schemas.microsoft.com/office/drawing/2014/main" id="{34F1F687-9D0E-453B-A241-20D09AEEF8CF}"/>
               </a:ext>
             </a:extLst>
           </p:cNvPr>
@@ -2654,27 +2643,27 @@
                 <a:ea typeface="Georgia"/>
                 <a:cs typeface="Georgia"/>
               </a:rPr>
-              <a:t>Путь пользователя</a:t>
+              <a:t>Карта потребностей города</a:t>
             </a:r>
           </a:p>
         </p:txBody>
       </p:sp>
       <p:pic>
         <p:nvPicPr>
-          <p:cNvPr id="16" name=""/>
+          <p:cNvPr id="11" name=""/>
           <p:cNvPicPr>
             <a:picLocks xmlns:a="http://schemas.openxmlformats.org/drawingml/2006/main" noChangeAspect="1"/>
           </p:cNvPicPr>
           <p:nvPr/>
         </p:nvPicPr>
         <p:blipFill>
-          <a:blip xmlns:r="http://schemas.openxmlformats.org/officeDocument/2006/relationships" xmlns:a="http://schemas.openxmlformats.org/drawingml/2006/main" r:embed="R031519761f8440c4"/>
+          <a:blip xmlns:r="http://schemas.openxmlformats.org/officeDocument/2006/relationships" xmlns:a="http://schemas.openxmlformats.org/drawingml/2006/main" r:embed="Rc5d76246d3ae4bf3"/>
           <a:stretch xmlns:a="http://schemas.openxmlformats.org/drawingml/2006/main"/>
         </p:blipFill>
         <p:spPr>
           <a:xfrm xmlns:a="http://schemas.openxmlformats.org/drawingml/2006/main">
-            <a:off x="629294" y="1619250"/>
-            <a:ext cx="6332838" cy="4686300"/>
+            <a:off x="4210822" y="1362075"/>
+            <a:ext cx="7504155" cy="5553075"/>
           </a:xfrm>
           <a:prstGeom xmlns:a="http://schemas.openxmlformats.org/drawingml/2006/main" prst="rect">
             <a:avLst/>
@@ -2686,7 +2675,7 @@
           <p:cNvPr id="3" name="">
             <a:extLst xmlns:a="http://schemas.openxmlformats.org/drawingml/2006/main">
               <a:ext uri="{FF2B5EF4-FFF2-40B4-BE49-F238E27FC236}">
-                <a16:creationId xmlns:a16="http://schemas.microsoft.com/office/drawing/2014/main" id="{B4124297-3B0C-40EB-91AF-482A32842B71}"/>
+                <a16:creationId xmlns:a16="http://schemas.microsoft.com/office/drawing/2014/main" id="{63AAEF43-3AAC-4CE1-9CFC-981C16EFC639}"/>
               </a:ext>
             </a:extLst>
           </p:cNvPr>
@@ -2697,8 +2686,8 @@
         </p:nvSpPr>
         <p:spPr>
           <a:xfrm xmlns:a="http://schemas.openxmlformats.org/drawingml/2006/main">
-            <a:off x="7400925" y="1733550"/>
-            <a:ext cx="685800" cy="381000"/>
+            <a:off x="695325" y="1809750"/>
+            <a:ext cx="619125" cy="361950"/>
           </a:xfrm>
           <a:prstGeom xmlns:a="http://schemas.openxmlformats.org/drawingml/2006/main" prst="rect">
             <a:avLst/>
@@ -2715,7 +2704,7 @@
           <a:lstStyle xmlns:a="http://schemas.openxmlformats.org/drawingml/2006/main"/>
           <a:p xmlns:a="http://schemas.openxmlformats.org/drawingml/2006/main">
             <a:pPr>
-              <a:defRPr sz="1800" b="1">
+              <a:defRPr sz="1650" b="1">
                 <a:solidFill>
                   <a:srgbClr val="AA7E32"/>
                 </a:solidFill>
@@ -2725,7 +2714,7 @@
               </a:defRPr>
             </a:pPr>
             <a:r>
-              <a:rPr sz="1800" b="1">
+              <a:rPr sz="1650" b="1">
                 <a:solidFill>
                   <a:srgbClr val="AA7E32"/>
                 </a:solidFill>
@@ -2743,7 +2732,7 @@
           <p:cNvPr id="4" name="">
             <a:extLst xmlns:a="http://schemas.openxmlformats.org/drawingml/2006/main">
               <a:ext uri="{FF2B5EF4-FFF2-40B4-BE49-F238E27FC236}">
-                <a16:creationId xmlns:a16="http://schemas.microsoft.com/office/drawing/2014/main" id="{8A37E299-A68B-4A3E-8435-A52CC33B65DA}"/>
+                <a16:creationId xmlns:a16="http://schemas.microsoft.com/office/drawing/2014/main" id="{B85E8E41-0A7D-4C4D-837C-E2F1965480AE}"/>
               </a:ext>
             </a:extLst>
           </p:cNvPr>
@@ -2754,8 +2743,8 @@
         </p:nvSpPr>
         <p:spPr>
           <a:xfrm xmlns:a="http://schemas.openxmlformats.org/drawingml/2006/main">
-            <a:off x="8001000" y="1704975"/>
-            <a:ext cx="3667125" cy="400050"/>
+            <a:off x="695325" y="2228850"/>
+            <a:ext cx="3333750" cy="523875"/>
           </a:xfrm>
           <a:prstGeom xmlns:a="http://schemas.openxmlformats.org/drawingml/2006/main" prst="rect">
             <a:avLst/>
@@ -2772,7 +2761,7 @@
           <a:lstStyle xmlns:a="http://schemas.openxmlformats.org/drawingml/2006/main"/>
           <a:p xmlns:a="http://schemas.openxmlformats.org/drawingml/2006/main">
             <a:pPr>
-              <a:defRPr sz="2100" b="1">
+              <a:defRPr sz="2325" b="1">
                 <a:solidFill>
                   <a:srgbClr val="183B36"/>
                 </a:solidFill>
@@ -2782,7 +2771,7 @@
               </a:defRPr>
             </a:pPr>
             <a:r>
-              <a:rPr sz="2100" b="1">
+              <a:rPr sz="2325" b="1">
                 <a:solidFill>
                   <a:srgbClr val="183B36"/>
                 </a:solidFill>
@@ -2790,7 +2779,7 @@
                 <a:ea typeface="Arial"/>
                 <a:cs typeface="Arial"/>
               </a:rPr>
-              <a:t>Карта и паспорт района</a:t>
+              <a:t>Изучить район</a:t>
             </a:r>
           </a:p>
         </p:txBody>
@@ -2800,7 +2789,7 @@
           <p:cNvPr id="5" name="">
             <a:extLst xmlns:a="http://schemas.openxmlformats.org/drawingml/2006/main">
               <a:ext uri="{FF2B5EF4-FFF2-40B4-BE49-F238E27FC236}">
-                <a16:creationId xmlns:a16="http://schemas.microsoft.com/office/drawing/2014/main" id="{EC990564-9EF8-41E9-92D8-BB332ED46F75}"/>
+                <a16:creationId xmlns:a16="http://schemas.microsoft.com/office/drawing/2014/main" id="{0220B54B-39ED-45FD-88F5-E9C283A639F1}"/>
               </a:ext>
             </a:extLst>
           </p:cNvPr>
@@ -2811,8 +2800,8 @@
         </p:nvSpPr>
         <p:spPr>
           <a:xfrm xmlns:a="http://schemas.openxmlformats.org/drawingml/2006/main">
-            <a:off x="8001000" y="2143125"/>
-            <a:ext cx="3429000" cy="657225"/>
+            <a:off x="695325" y="2828925"/>
+            <a:ext cx="3143250" cy="866775"/>
           </a:xfrm>
           <a:prstGeom xmlns:a="http://schemas.openxmlformats.org/drawingml/2006/main" prst="rect">
             <a:avLst/>
@@ -2829,7 +2818,7 @@
           <a:lstStyle xmlns:a="http://schemas.openxmlformats.org/drawingml/2006/main"/>
           <a:p xmlns:a="http://schemas.openxmlformats.org/drawingml/2006/main">
             <a:pPr>
-              <a:defRPr sz="1725" b="0">
+              <a:defRPr sz="1950" b="0">
                 <a:solidFill>
                   <a:srgbClr val="62736B"/>
                 </a:solidFill>
@@ -2839,7 +2828,7 @@
               </a:defRPr>
             </a:pPr>
             <a:r>
-              <a:rPr sz="1725" b="0">
+              <a:rPr sz="1950" b="0">
                 <a:solidFill>
                   <a:srgbClr val="62736B"/>
                 </a:solidFill>
@@ -2847,7 +2836,30 @@
                 <a:ea typeface="Arial"/>
                 <a:cs typeface="Arial"/>
               </a:rPr>
-              <a:t>Исходные показатели и проблемные места</a:t>
+              <a:t>Карта и паспорт</a:t>
+            </a:r>
+          </a:p>
+          <a:p xmlns:a="http://schemas.openxmlformats.org/drawingml/2006/main">
+            <a:pPr>
+              <a:defRPr sz="1950" b="0">
+                <a:solidFill>
+                  <a:srgbClr val="62736B"/>
+                </a:solidFill>
+                <a:latin typeface="Arial"/>
+                <a:ea typeface="Arial"/>
+                <a:cs typeface="Arial"/>
+              </a:defRPr>
+            </a:pPr>
+            <a:r>
+              <a:rPr sz="1950" b="0">
+                <a:solidFill>
+                  <a:srgbClr val="62736B"/>
+                </a:solidFill>
+                <a:latin typeface="Arial"/>
+                <a:ea typeface="Arial"/>
+                <a:cs typeface="Arial"/>
+              </a:rPr>
+              <a:t>показывают потребности</a:t>
             </a:r>
           </a:p>
         </p:txBody>
@@ -2857,7 +2869,7 @@
           <p:cNvPr id="6" name="">
             <a:extLst xmlns:a="http://schemas.openxmlformats.org/drawingml/2006/main">
               <a:ext uri="{FF2B5EF4-FFF2-40B4-BE49-F238E27FC236}">
-                <a16:creationId xmlns:a16="http://schemas.microsoft.com/office/drawing/2014/main" id="{1E03E91C-91BB-415D-9317-13B678225B33}"/>
+                <a16:creationId xmlns:a16="http://schemas.microsoft.com/office/drawing/2014/main" id="{0D259D2A-7B6B-47BD-B616-7BAB788B2D17}"/>
               </a:ext>
             </a:extLst>
           </p:cNvPr>
@@ -2868,8 +2880,8 @@
         </p:nvSpPr>
         <p:spPr>
           <a:xfrm xmlns:a="http://schemas.openxmlformats.org/drawingml/2006/main">
-            <a:off x="7400925" y="2847975"/>
-            <a:ext cx="685800" cy="381000"/>
+            <a:off x="695325" y="3952875"/>
+            <a:ext cx="619125" cy="361950"/>
           </a:xfrm>
           <a:prstGeom xmlns:a="http://schemas.openxmlformats.org/drawingml/2006/main" prst="rect">
             <a:avLst/>
@@ -2886,7 +2898,7 @@
           <a:lstStyle xmlns:a="http://schemas.openxmlformats.org/drawingml/2006/main"/>
           <a:p xmlns:a="http://schemas.openxmlformats.org/drawingml/2006/main">
             <a:pPr>
-              <a:defRPr sz="1800" b="1">
+              <a:defRPr sz="1650" b="1">
                 <a:solidFill>
                   <a:srgbClr val="AA7E32"/>
                 </a:solidFill>
@@ -2896,7 +2908,7 @@
               </a:defRPr>
             </a:pPr>
             <a:r>
-              <a:rPr sz="1800" b="1">
+              <a:rPr sz="1650" b="1">
                 <a:solidFill>
                   <a:srgbClr val="AA7E32"/>
                 </a:solidFill>
@@ -2914,7 +2926,7 @@
           <p:cNvPr id="7" name="">
             <a:extLst xmlns:a="http://schemas.openxmlformats.org/drawingml/2006/main">
               <a:ext uri="{FF2B5EF4-FFF2-40B4-BE49-F238E27FC236}">
-                <a16:creationId xmlns:a16="http://schemas.microsoft.com/office/drawing/2014/main" id="{407CAD7C-20F1-4914-A9A5-3FCC478A0746}"/>
+                <a16:creationId xmlns:a16="http://schemas.microsoft.com/office/drawing/2014/main" id="{B0AAA3D9-AAE1-4DBB-9B9A-4B3489031E92}"/>
               </a:ext>
             </a:extLst>
           </p:cNvPr>
@@ -2925,8 +2937,8 @@
         </p:nvSpPr>
         <p:spPr>
           <a:xfrm xmlns:a="http://schemas.openxmlformats.org/drawingml/2006/main">
-            <a:off x="8001000" y="2819400"/>
-            <a:ext cx="3667125" cy="400050"/>
+            <a:off x="695325" y="4371975"/>
+            <a:ext cx="3333750" cy="523875"/>
           </a:xfrm>
           <a:prstGeom xmlns:a="http://schemas.openxmlformats.org/drawingml/2006/main" prst="rect">
             <a:avLst/>
@@ -2943,7 +2955,7 @@
           <a:lstStyle xmlns:a="http://schemas.openxmlformats.org/drawingml/2006/main"/>
           <a:p xmlns:a="http://schemas.openxmlformats.org/drawingml/2006/main">
             <a:pPr>
-              <a:defRPr sz="2100" b="1">
+              <a:defRPr sz="2325" b="1">
                 <a:solidFill>
                   <a:srgbClr val="183B36"/>
                 </a:solidFill>
@@ -2953,7 +2965,7 @@
               </a:defRPr>
             </a:pPr>
             <a:r>
-              <a:rPr sz="2100" b="1">
+              <a:rPr sz="2325" b="1">
                 <a:solidFill>
                   <a:srgbClr val="183B36"/>
                 </a:solidFill>
@@ -2961,7 +2973,7 @@
                 <a:ea typeface="Arial"/>
                 <a:cs typeface="Arial"/>
               </a:rPr>
-              <a:t>Выбор пяти мер</a:t>
+              <a:t>Выбрать меры</a:t>
             </a:r>
           </a:p>
         </p:txBody>
@@ -2971,7 +2983,7 @@
           <p:cNvPr id="8" name="">
             <a:extLst xmlns:a="http://schemas.openxmlformats.org/drawingml/2006/main">
               <a:ext uri="{FF2B5EF4-FFF2-40B4-BE49-F238E27FC236}">
-                <a16:creationId xmlns:a16="http://schemas.microsoft.com/office/drawing/2014/main" id="{34802C55-5694-4C9D-8DDC-2FFEB65D9FF9}"/>
+                <a16:creationId xmlns:a16="http://schemas.microsoft.com/office/drawing/2014/main" id="{758AC96A-900E-4C20-95C7-35F94EF4D601}"/>
               </a:ext>
             </a:extLst>
           </p:cNvPr>
@@ -2982,8 +2994,8 @@
         </p:nvSpPr>
         <p:spPr>
           <a:xfrm xmlns:a="http://schemas.openxmlformats.org/drawingml/2006/main">
-            <a:off x="8001000" y="3257550"/>
-            <a:ext cx="3429000" cy="657225"/>
+            <a:off x="695325" y="4972050"/>
+            <a:ext cx="3143250" cy="866775"/>
           </a:xfrm>
           <a:prstGeom xmlns:a="http://schemas.openxmlformats.org/drawingml/2006/main" prst="rect">
             <a:avLst/>
@@ -3000,7 +3012,7 @@
           <a:lstStyle xmlns:a="http://schemas.openxmlformats.org/drawingml/2006/main"/>
           <a:p xmlns:a="http://schemas.openxmlformats.org/drawingml/2006/main">
             <a:pPr>
-              <a:defRPr sz="1725" b="0">
+              <a:defRPr sz="1950" b="0">
                 <a:solidFill>
                   <a:srgbClr val="62736B"/>
                 </a:solidFill>
@@ -3010,7 +3022,7 @@
               </a:defRPr>
             </a:pPr>
             <a:r>
-              <a:rPr sz="1725" b="0">
+              <a:rPr sz="1950" b="0">
                 <a:solidFill>
                   <a:srgbClr val="62736B"/>
                 </a:solidFill>
@@ -3018,7 +3030,30 @@
                 <a:ea typeface="Arial"/>
                 <a:cs typeface="Arial"/>
               </a:rPr>
-              <a:t>Район реализации и остаток бюджета</a:t>
+              <a:t>Бюджет виден</a:t>
+            </a:r>
+          </a:p>
+          <a:p xmlns:a="http://schemas.openxmlformats.org/drawingml/2006/main">
+            <a:pPr>
+              <a:defRPr sz="1950" b="0">
+                <a:solidFill>
+                  <a:srgbClr val="62736B"/>
+                </a:solidFill>
+                <a:latin typeface="Arial"/>
+                <a:ea typeface="Arial"/>
+                <a:cs typeface="Arial"/>
+              </a:defRPr>
+            </a:pPr>
+            <a:r>
+              <a:rPr sz="1950" b="0">
+                <a:solidFill>
+                  <a:srgbClr val="62736B"/>
+                </a:solidFill>
+                <a:latin typeface="Arial"/>
+                <a:ea typeface="Arial"/>
+                <a:cs typeface="Arial"/>
+              </a:rPr>
+              <a:t>во время выбора</a:t>
             </a:r>
           </a:p>
         </p:txBody>
@@ -3028,7 +3063,7 @@
           <p:cNvPr id="9" name="">
             <a:extLst xmlns:a="http://schemas.openxmlformats.org/drawingml/2006/main">
               <a:ext uri="{FF2B5EF4-FFF2-40B4-BE49-F238E27FC236}">
-                <a16:creationId xmlns:a16="http://schemas.microsoft.com/office/drawing/2014/main" id="{F431B6D4-B547-4D72-B3CA-7965FEBFCA32}"/>
+                <a16:creationId xmlns:a16="http://schemas.microsoft.com/office/drawing/2014/main" id="{41C86BD2-6609-4214-9918-8A29C1A9530C}"/>
               </a:ext>
             </a:extLst>
           </p:cNvPr>
@@ -3039,8 +3074,8 @@
         </p:nvSpPr>
         <p:spPr>
           <a:xfrm xmlns:a="http://schemas.openxmlformats.org/drawingml/2006/main">
-            <a:off x="7400925" y="3962400"/>
-            <a:ext cx="685800" cy="381000"/>
+            <a:off x="695325" y="6162675"/>
+            <a:ext cx="3619500" cy="371475"/>
           </a:xfrm>
           <a:prstGeom xmlns:a="http://schemas.openxmlformats.org/drawingml/2006/main" prst="rect">
             <a:avLst/>
@@ -3057,310 +3092,25 @@
           <a:lstStyle xmlns:a="http://schemas.openxmlformats.org/drawingml/2006/main"/>
           <a:p xmlns:a="http://schemas.openxmlformats.org/drawingml/2006/main">
             <a:pPr>
-              <a:defRPr sz="1800" b="1">
-                <a:solidFill>
-                  <a:srgbClr val="AA7E32"/>
-                </a:solidFill>
-                <a:latin typeface="Arial"/>
-                <a:ea typeface="Arial"/>
-                <a:cs typeface="Arial"/>
-              </a:defRPr>
-            </a:pPr>
-            <a:r>
-              <a:rPr sz="1800" b="1">
-                <a:solidFill>
-                  <a:srgbClr val="AA7E32"/>
-                </a:solidFill>
-                <a:latin typeface="Arial"/>
-                <a:ea typeface="Arial"/>
-                <a:cs typeface="Arial"/>
-              </a:rPr>
-              <a:t>03</a:t>
-            </a:r>
-          </a:p>
-        </p:txBody>
-      </p:sp>
-      <p:sp>
-        <p:nvSpPr>
-          <p:cNvPr id="10" name="">
-            <a:extLst xmlns:a="http://schemas.openxmlformats.org/drawingml/2006/main">
-              <a:ext uri="{FF2B5EF4-FFF2-40B4-BE49-F238E27FC236}">
-                <a16:creationId xmlns:a16="http://schemas.microsoft.com/office/drawing/2014/main" id="{683DFCB4-8965-4F1B-81F1-A70E91E08C72}"/>
-              </a:ext>
-            </a:extLst>
-          </p:cNvPr>
-          <p:cNvSpPr>
-            <a:spLocks xmlns:a="http://schemas.openxmlformats.org/drawingml/2006/main" noGrp="1"/>
-          </p:cNvSpPr>
-          <p:nvPr/>
-        </p:nvSpPr>
-        <p:spPr>
-          <a:xfrm xmlns:a="http://schemas.openxmlformats.org/drawingml/2006/main">
-            <a:off x="8001000" y="3933825"/>
-            <a:ext cx="3667125" cy="400050"/>
-          </a:xfrm>
-          <a:prstGeom xmlns:a="http://schemas.openxmlformats.org/drawingml/2006/main" prst="rect">
-            <a:avLst/>
-          </a:prstGeom>
-          <a:noFill xmlns:a="http://schemas.openxmlformats.org/drawingml/2006/main"/>
-          <a:ln xmlns:a="http://schemas.openxmlformats.org/drawingml/2006/main" w="0">
-            <a:noFill/>
-          </a:ln>
-        </p:spPr>
-        <p:txBody>
-          <a:bodyPr xmlns:a="http://schemas.openxmlformats.org/drawingml/2006/main">
-            <a:noAutofit/>
-          </a:bodyPr>
-          <a:lstStyle xmlns:a="http://schemas.openxmlformats.org/drawingml/2006/main"/>
-          <a:p xmlns:a="http://schemas.openxmlformats.org/drawingml/2006/main">
-            <a:pPr>
-              <a:defRPr sz="2100" b="1">
-                <a:solidFill>
-                  <a:srgbClr val="183B36"/>
-                </a:solidFill>
-                <a:latin typeface="Arial"/>
-                <a:ea typeface="Arial"/>
-                <a:cs typeface="Arial"/>
-              </a:defRPr>
-            </a:pPr>
-            <a:r>
-              <a:rPr sz="2100" b="1">
-                <a:solidFill>
-                  <a:srgbClr val="183B36"/>
-                </a:solidFill>
-                <a:latin typeface="Arial"/>
-                <a:ea typeface="Arial"/>
-                <a:cs typeface="Arial"/>
-              </a:rPr>
-              <a:t>Расчёт последствий</a:t>
-            </a:r>
-          </a:p>
-        </p:txBody>
-      </p:sp>
-      <p:sp>
-        <p:nvSpPr>
-          <p:cNvPr id="11" name="">
-            <a:extLst xmlns:a="http://schemas.openxmlformats.org/drawingml/2006/main">
-              <a:ext uri="{FF2B5EF4-FFF2-40B4-BE49-F238E27FC236}">
-                <a16:creationId xmlns:a16="http://schemas.microsoft.com/office/drawing/2014/main" id="{D9E8514F-75F8-4939-8101-101B3F6EF8B4}"/>
-              </a:ext>
-            </a:extLst>
-          </p:cNvPr>
-          <p:cNvSpPr>
-            <a:spLocks xmlns:a="http://schemas.openxmlformats.org/drawingml/2006/main" noGrp="1"/>
-          </p:cNvSpPr>
-          <p:nvPr/>
-        </p:nvSpPr>
-        <p:spPr>
-          <a:xfrm xmlns:a="http://schemas.openxmlformats.org/drawingml/2006/main">
-            <a:off x="8001000" y="4371975"/>
-            <a:ext cx="3429000" cy="657225"/>
-          </a:xfrm>
-          <a:prstGeom xmlns:a="http://schemas.openxmlformats.org/drawingml/2006/main" prst="rect">
-            <a:avLst/>
-          </a:prstGeom>
-          <a:noFill xmlns:a="http://schemas.openxmlformats.org/drawingml/2006/main"/>
-          <a:ln xmlns:a="http://schemas.openxmlformats.org/drawingml/2006/main" w="0">
-            <a:noFill/>
-          </a:ln>
-        </p:spPr>
-        <p:txBody>
-          <a:bodyPr xmlns:a="http://schemas.openxmlformats.org/drawingml/2006/main">
-            <a:noAutofit/>
-          </a:bodyPr>
-          <a:lstStyle xmlns:a="http://schemas.openxmlformats.org/drawingml/2006/main"/>
-          <a:p xmlns:a="http://schemas.openxmlformats.org/drawingml/2006/main">
-            <a:pPr>
-              <a:defRPr sz="1725" b="0">
-                <a:solidFill>
-                  <a:srgbClr val="62736B"/>
-                </a:solidFill>
-                <a:latin typeface="Arial"/>
-                <a:ea typeface="Arial"/>
-                <a:cs typeface="Arial"/>
-              </a:defRPr>
-            </a:pPr>
-            <a:r>
-              <a:rPr sz="1725" b="0">
-                <a:solidFill>
-                  <a:srgbClr val="62736B"/>
-                </a:solidFill>
-                <a:latin typeface="Arial"/>
-                <a:ea typeface="Arial"/>
-                <a:cs typeface="Arial"/>
-              </a:rPr>
-              <a:t>Изменения районов и общий Score</a:t>
-            </a:r>
-          </a:p>
-        </p:txBody>
-      </p:sp>
-      <p:sp>
-        <p:nvSpPr>
-          <p:cNvPr id="12" name="">
-            <a:extLst xmlns:a="http://schemas.openxmlformats.org/drawingml/2006/main">
-              <a:ext uri="{FF2B5EF4-FFF2-40B4-BE49-F238E27FC236}">
-                <a16:creationId xmlns:a16="http://schemas.microsoft.com/office/drawing/2014/main" id="{532C4DF1-DF5C-489B-BEFE-C7A0C7E108D6}"/>
-              </a:ext>
-            </a:extLst>
-          </p:cNvPr>
-          <p:cNvSpPr>
-            <a:spLocks xmlns:a="http://schemas.openxmlformats.org/drawingml/2006/main" noGrp="1"/>
-          </p:cNvSpPr>
-          <p:nvPr/>
-        </p:nvSpPr>
-        <p:spPr>
-          <a:xfrm xmlns:a="http://schemas.openxmlformats.org/drawingml/2006/main">
-            <a:off x="7400925" y="5076825"/>
-            <a:ext cx="685800" cy="381000"/>
-          </a:xfrm>
-          <a:prstGeom xmlns:a="http://schemas.openxmlformats.org/drawingml/2006/main" prst="rect">
-            <a:avLst/>
-          </a:prstGeom>
-          <a:noFill xmlns:a="http://schemas.openxmlformats.org/drawingml/2006/main"/>
-          <a:ln xmlns:a="http://schemas.openxmlformats.org/drawingml/2006/main" w="0">
-            <a:noFill/>
-          </a:ln>
-        </p:spPr>
-        <p:txBody>
-          <a:bodyPr xmlns:a="http://schemas.openxmlformats.org/drawingml/2006/main">
-            <a:noAutofit/>
-          </a:bodyPr>
-          <a:lstStyle xmlns:a="http://schemas.openxmlformats.org/drawingml/2006/main"/>
-          <a:p xmlns:a="http://schemas.openxmlformats.org/drawingml/2006/main">
-            <a:pPr>
-              <a:defRPr sz="1800" b="1">
-                <a:solidFill>
-                  <a:srgbClr val="AA7E32"/>
-                </a:solidFill>
-                <a:latin typeface="Arial"/>
-                <a:ea typeface="Arial"/>
-                <a:cs typeface="Arial"/>
-              </a:defRPr>
-            </a:pPr>
-            <a:r>
-              <a:rPr sz="1800" b="1">
-                <a:solidFill>
-                  <a:srgbClr val="AA7E32"/>
-                </a:solidFill>
-                <a:latin typeface="Arial"/>
-                <a:ea typeface="Arial"/>
-                <a:cs typeface="Arial"/>
-              </a:rPr>
-              <a:t>04</a:t>
-            </a:r>
-          </a:p>
-        </p:txBody>
-      </p:sp>
-      <p:sp>
-        <p:nvSpPr>
-          <p:cNvPr id="13" name="">
-            <a:extLst xmlns:a="http://schemas.openxmlformats.org/drawingml/2006/main">
-              <a:ext uri="{FF2B5EF4-FFF2-40B4-BE49-F238E27FC236}">
-                <a16:creationId xmlns:a16="http://schemas.microsoft.com/office/drawing/2014/main" id="{D516D857-ED20-4EE2-907A-C062C6C0F6B8}"/>
-              </a:ext>
-            </a:extLst>
-          </p:cNvPr>
-          <p:cNvSpPr>
-            <a:spLocks xmlns:a="http://schemas.openxmlformats.org/drawingml/2006/main" noGrp="1"/>
-          </p:cNvSpPr>
-          <p:nvPr/>
-        </p:nvSpPr>
-        <p:spPr>
-          <a:xfrm xmlns:a="http://schemas.openxmlformats.org/drawingml/2006/main">
-            <a:off x="8001000" y="5048250"/>
-            <a:ext cx="3667125" cy="400050"/>
-          </a:xfrm>
-          <a:prstGeom xmlns:a="http://schemas.openxmlformats.org/drawingml/2006/main" prst="rect">
-            <a:avLst/>
-          </a:prstGeom>
-          <a:noFill xmlns:a="http://schemas.openxmlformats.org/drawingml/2006/main"/>
-          <a:ln xmlns:a="http://schemas.openxmlformats.org/drawingml/2006/main" w="0">
-            <a:noFill/>
-          </a:ln>
-        </p:spPr>
-        <p:txBody>
-          <a:bodyPr xmlns:a="http://schemas.openxmlformats.org/drawingml/2006/main">
-            <a:noAutofit/>
-          </a:bodyPr>
-          <a:lstStyle xmlns:a="http://schemas.openxmlformats.org/drawingml/2006/main"/>
-          <a:p xmlns:a="http://schemas.openxmlformats.org/drawingml/2006/main">
-            <a:pPr>
-              <a:defRPr sz="2100" b="1">
-                <a:solidFill>
-                  <a:srgbClr val="183B36"/>
-                </a:solidFill>
-                <a:latin typeface="Arial"/>
-                <a:ea typeface="Arial"/>
-                <a:cs typeface="Arial"/>
-              </a:defRPr>
-            </a:pPr>
-            <a:r>
-              <a:rPr sz="2100" b="1">
-                <a:solidFill>
-                  <a:srgbClr val="183B36"/>
-                </a:solidFill>
-                <a:latin typeface="Arial"/>
-                <a:ea typeface="Arial"/>
-                <a:cs typeface="Arial"/>
-              </a:rPr>
-              <a:t>Сравнение A/B</a:t>
-            </a:r>
-          </a:p>
-        </p:txBody>
-      </p:sp>
-      <p:sp>
-        <p:nvSpPr>
-          <p:cNvPr id="14" name="">
-            <a:extLst xmlns:a="http://schemas.openxmlformats.org/drawingml/2006/main">
-              <a:ext uri="{FF2B5EF4-FFF2-40B4-BE49-F238E27FC236}">
-                <a16:creationId xmlns:a16="http://schemas.microsoft.com/office/drawing/2014/main" id="{F80D3C39-82CB-4DFE-B403-18EA9B1C7B81}"/>
-              </a:ext>
-            </a:extLst>
-          </p:cNvPr>
-          <p:cNvSpPr>
-            <a:spLocks xmlns:a="http://schemas.openxmlformats.org/drawingml/2006/main" noGrp="1"/>
-          </p:cNvSpPr>
-          <p:nvPr/>
-        </p:nvSpPr>
-        <p:spPr>
-          <a:xfrm xmlns:a="http://schemas.openxmlformats.org/drawingml/2006/main">
-            <a:off x="8001000" y="5486400"/>
-            <a:ext cx="3429000" cy="657225"/>
-          </a:xfrm>
-          <a:prstGeom xmlns:a="http://schemas.openxmlformats.org/drawingml/2006/main" prst="rect">
-            <a:avLst/>
-          </a:prstGeom>
-          <a:noFill xmlns:a="http://schemas.openxmlformats.org/drawingml/2006/main"/>
-          <a:ln xmlns:a="http://schemas.openxmlformats.org/drawingml/2006/main" w="0">
-            <a:noFill/>
-          </a:ln>
-        </p:spPr>
-        <p:txBody>
-          <a:bodyPr xmlns:a="http://schemas.openxmlformats.org/drawingml/2006/main">
-            <a:noAutofit/>
-          </a:bodyPr>
-          <a:lstStyle xmlns:a="http://schemas.openxmlformats.org/drawingml/2006/main"/>
-          <a:p xmlns:a="http://schemas.openxmlformats.org/drawingml/2006/main">
-            <a:pPr>
-              <a:defRPr sz="1725" b="0">
-                <a:solidFill>
-                  <a:srgbClr val="62736B"/>
-                </a:solidFill>
-                <a:latin typeface="Arial"/>
-                <a:ea typeface="Arial"/>
-                <a:cs typeface="Arial"/>
-              </a:defRPr>
-            </a:pPr>
-            <a:r>
-              <a:rPr sz="1725" b="0">
-                <a:solidFill>
-                  <a:srgbClr val="62736B"/>
-                </a:solidFill>
-                <a:latin typeface="Arial"/>
-                <a:ea typeface="Arial"/>
-                <a:cs typeface="Arial"/>
-              </a:rPr>
-              <a:t>Сохранение и восстановление A</a:t>
+              <a:defRPr sz="1875" b="1">
+                <a:solidFill>
+                  <a:srgbClr val="194E42"/>
+                </a:solidFill>
+                <a:latin typeface="Arial"/>
+                <a:ea typeface="Arial"/>
+                <a:cs typeface="Arial"/>
+              </a:defRPr>
+            </a:pPr>
+            <a:r>
+              <a:rPr sz="1875" b="1">
+                <a:solidFill>
+                  <a:srgbClr val="194E42"/>
+                </a:solidFill>
+                <a:latin typeface="Arial"/>
+                <a:ea typeface="Arial"/>
+                <a:cs typeface="Arial"/>
+              </a:rPr>
+              <a:t>Расчёт и сравнение A/B</a:t>
             </a:r>
           </a:p>
         </p:txBody>
@@ -3368,7 +3118,7 @@
     </p:spTree>
     <p:extLst>
       <p:ext uri="{BB962C8B-B14F-4D97-AF65-F5344CB8AC3E}">
-        <p14:creationId xmlns:p14="http://schemas.microsoft.com/office/powerpoint/2010/main" val="418379858"/>
+        <p14:creationId xmlns:p14="http://schemas.microsoft.com/office/powerpoint/2010/main" val="1440563890"/>
       </p:ext>
     </p:extLst>
   </p:cSld>
@@ -3381,7 +3131,7 @@
     <p:bg>
       <p:bgPr>
         <a:solidFill xmlns:a="http://schemas.openxmlformats.org/drawingml/2006/main">
-          <a:srgbClr val="F5F2E8"/>
+          <a:srgbClr val="194E42"/>
         </a:solidFill>
       </p:bgPr>
     </p:bg>
@@ -3399,7 +3149,7 @@
           <p:cNvPr id="8" name="">
             <a:extLst xmlns:a="http://schemas.openxmlformats.org/drawingml/2006/main">
               <a:ext uri="{FF2B5EF4-FFF2-40B4-BE49-F238E27FC236}">
-                <a16:creationId xmlns:a16="http://schemas.microsoft.com/office/drawing/2014/main" id="{D33E14ED-972F-46EE-97CA-88B457BF47B9}"/>
+                <a16:creationId xmlns:a16="http://schemas.microsoft.com/office/drawing/2014/main" id="{4F5CCC9E-9129-4C1E-ACDC-320BCA248299}"/>
               </a:ext>
             </a:extLst>
           </p:cNvPr>
@@ -3411,7 +3161,7 @@
         <p:spPr>
           <a:xfrm xmlns:a="http://schemas.openxmlformats.org/drawingml/2006/main">
             <a:off x="628650" y="495300"/>
-            <a:ext cx="10934700" cy="876300"/>
+            <a:ext cx="10934700" cy="914400"/>
           </a:xfrm>
           <a:prstGeom xmlns:a="http://schemas.openxmlformats.org/drawingml/2006/main" prst="rect">
             <a:avLst/>
@@ -3428,9 +3178,9 @@
           <a:lstStyle xmlns:a="http://schemas.openxmlformats.org/drawingml/2006/main"/>
           <a:p xmlns:a="http://schemas.openxmlformats.org/drawingml/2006/main">
             <a:pPr>
-              <a:defRPr sz="3375" b="0">
-                <a:solidFill>
-                  <a:srgbClr val="183B36"/>
+              <a:defRPr sz="3600" b="0">
+                <a:solidFill>
+                  <a:srgbClr val="F5F2E8"/>
                 </a:solidFill>
                 <a:latin typeface="Georgia"/>
                 <a:ea typeface="Georgia"/>
@@ -3438,15 +3188,15 @@
               </a:defRPr>
             </a:pPr>
             <a:r>
-              <a:rPr sz="3375" b="0">
-                <a:solidFill>
-                  <a:srgbClr val="183B36"/>
+              <a:rPr sz="3600" b="0">
+                <a:solidFill>
+                  <a:srgbClr val="F5F2E8"/>
                 </a:solidFill>
                 <a:latin typeface="Georgia"/>
                 <a:ea typeface="Georgia"/>
                 <a:cs typeface="Georgia"/>
               </a:rPr>
-              <a:t>Расчёт и роль AI</a:t>
+              <a:t>Python считает. AI объясняет</a:t>
             </a:r>
           </a:p>
         </p:txBody>
@@ -3456,7 +3206,7 @@
           <p:cNvPr id="2" name="">
             <a:extLst xmlns:a="http://schemas.openxmlformats.org/drawingml/2006/main">
               <a:ext uri="{FF2B5EF4-FFF2-40B4-BE49-F238E27FC236}">
-                <a16:creationId xmlns:a16="http://schemas.microsoft.com/office/drawing/2014/main" id="{5162D938-F13E-450F-8BF6-DBB2C46027C5}"/>
+                <a16:creationId xmlns:a16="http://schemas.microsoft.com/office/drawing/2014/main" id="{2297B258-5F80-441F-9F81-DC79CD33E955}"/>
               </a:ext>
             </a:extLst>
           </p:cNvPr>
@@ -3467,8 +3217,8 @@
         </p:nvSpPr>
         <p:spPr>
           <a:xfrm xmlns:a="http://schemas.openxmlformats.org/drawingml/2006/main">
-            <a:off x="685800" y="1800225"/>
-            <a:ext cx="4953000" cy="571500"/>
+            <a:off x="695325" y="2143125"/>
+            <a:ext cx="4857750" cy="781050"/>
           </a:xfrm>
           <a:prstGeom xmlns:a="http://schemas.openxmlformats.org/drawingml/2006/main" prst="rect">
             <a:avLst/>
@@ -3485,25 +3235,25 @@
           <a:lstStyle xmlns:a="http://schemas.openxmlformats.org/drawingml/2006/main"/>
           <a:p xmlns:a="http://schemas.openxmlformats.org/drawingml/2006/main">
             <a:pPr>
-              <a:defRPr sz="2625" b="1">
-                <a:solidFill>
-                  <a:srgbClr val="194E42"/>
-                </a:solidFill>
-                <a:latin typeface="Arial"/>
-                <a:ea typeface="Arial"/>
-                <a:cs typeface="Arial"/>
-              </a:defRPr>
-            </a:pPr>
-            <a:r>
-              <a:rPr sz="2625" b="1">
-                <a:solidFill>
-                  <a:srgbClr val="194E42"/>
-                </a:solidFill>
-                <a:latin typeface="Arial"/>
-                <a:ea typeface="Arial"/>
-                <a:cs typeface="Arial"/>
-              </a:rPr>
-              <a:t>Python считает</a:t>
+              <a:defRPr sz="4350" b="1">
+                <a:solidFill>
+                  <a:srgbClr val="F5F2E8"/>
+                </a:solidFill>
+                <a:latin typeface="Arial"/>
+                <a:ea typeface="Arial"/>
+                <a:cs typeface="Arial"/>
+              </a:defRPr>
+            </a:pPr>
+            <a:r>
+              <a:rPr sz="4350" b="1">
+                <a:solidFill>
+                  <a:srgbClr val="F5F2E8"/>
+                </a:solidFill>
+                <a:latin typeface="Arial"/>
+                <a:ea typeface="Arial"/>
+                <a:cs typeface="Arial"/>
+              </a:rPr>
+              <a:t>Python</a:t>
             </a:r>
           </a:p>
         </p:txBody>
@@ -3513,7 +3263,7 @@
           <p:cNvPr id="3" name="">
             <a:extLst xmlns:a="http://schemas.openxmlformats.org/drawingml/2006/main">
               <a:ext uri="{FF2B5EF4-FFF2-40B4-BE49-F238E27FC236}">
-                <a16:creationId xmlns:a16="http://schemas.microsoft.com/office/drawing/2014/main" id="{3D4F7F29-F319-4A10-8A5B-F6FAD2916ED4}"/>
+                <a16:creationId xmlns:a16="http://schemas.microsoft.com/office/drawing/2014/main" id="{08CE96A2-C944-4AA5-B044-8F41A06DFFBD}"/>
               </a:ext>
             </a:extLst>
           </p:cNvPr>
@@ -3524,8 +3274,8 @@
         </p:nvSpPr>
         <p:spPr>
           <a:xfrm xmlns:a="http://schemas.openxmlformats.org/drawingml/2006/main">
-            <a:off x="685800" y="2705100"/>
-            <a:ext cx="4953000" cy="1743075"/>
+            <a:off x="695325" y="3295650"/>
+            <a:ext cx="4953000" cy="1562100"/>
           </a:xfrm>
           <a:prstGeom xmlns:a="http://schemas.openxmlformats.org/drawingml/2006/main" prst="rect">
             <a:avLst/>
@@ -3542,71 +3292,71 @@
           <a:lstStyle xmlns:a="http://schemas.openxmlformats.org/drawingml/2006/main"/>
           <a:p xmlns:a="http://schemas.openxmlformats.org/drawingml/2006/main">
             <a:pPr>
-              <a:defRPr sz="2100" b="0">
-                <a:solidFill>
-                  <a:srgbClr val="183B36"/>
-                </a:solidFill>
-                <a:latin typeface="Arial"/>
-                <a:ea typeface="Arial"/>
-                <a:cs typeface="Arial"/>
-              </a:defRPr>
-            </a:pPr>
-            <a:r>
-              <a:rPr sz="2100" b="0">
-                <a:solidFill>
-                  <a:srgbClr val="183B36"/>
-                </a:solidFill>
-                <a:latin typeface="Arial"/>
-                <a:ea typeface="Arial"/>
-                <a:cs typeface="Arial"/>
-              </a:rPr>
-              <a:t>Проверяет бюджет и совместимость</a:t>
-            </a:r>
-          </a:p>
-          <a:p xmlns:a="http://schemas.openxmlformats.org/drawingml/2006/main">
-            <a:pPr>
-              <a:defRPr sz="2100" b="0">
-                <a:solidFill>
-                  <a:srgbClr val="183B36"/>
-                </a:solidFill>
-                <a:latin typeface="Arial"/>
-                <a:ea typeface="Arial"/>
-                <a:cs typeface="Arial"/>
-              </a:defRPr>
-            </a:pPr>
-            <a:r>
-              <a:rPr sz="2100" b="0">
-                <a:solidFill>
-                  <a:srgbClr val="183B36"/>
+              <a:defRPr sz="2175" b="0">
+                <a:solidFill>
+                  <a:srgbClr val="F5F2E8"/>
+                </a:solidFill>
+                <a:latin typeface="Arial"/>
+                <a:ea typeface="Arial"/>
+                <a:cs typeface="Arial"/>
+              </a:defRPr>
+            </a:pPr>
+            <a:r>
+              <a:rPr sz="2175" b="0">
+                <a:solidFill>
+                  <a:srgbClr val="F5F2E8"/>
+                </a:solidFill>
+                <a:latin typeface="Arial"/>
+                <a:ea typeface="Arial"/>
+                <a:cs typeface="Arial"/>
+              </a:rPr>
+              <a:t>Проверяет правила</a:t>
+            </a:r>
+          </a:p>
+          <a:p xmlns:a="http://schemas.openxmlformats.org/drawingml/2006/main">
+            <a:pPr>
+              <a:defRPr sz="2175" b="0">
+                <a:solidFill>
+                  <a:srgbClr val="F5F2E8"/>
+                </a:solidFill>
+                <a:latin typeface="Arial"/>
+                <a:ea typeface="Arial"/>
+                <a:cs typeface="Arial"/>
+              </a:defRPr>
+            </a:pPr>
+            <a:r>
+              <a:rPr sz="2175" b="0">
+                <a:solidFill>
+                  <a:srgbClr val="F5F2E8"/>
+                </a:solidFill>
+                <a:latin typeface="Arial"/>
+                <a:ea typeface="Arial"/>
+                <a:cs typeface="Arial"/>
+              </a:rPr>
+              <a:t>Рассчитывает показатели</a:t>
+            </a:r>
+          </a:p>
+          <a:p xmlns:a="http://schemas.openxmlformats.org/drawingml/2006/main">
+            <a:pPr>
+              <a:defRPr sz="2175" b="0">
+                <a:solidFill>
+                  <a:srgbClr val="F5F2E8"/>
+                </a:solidFill>
+                <a:latin typeface="Arial"/>
+                <a:ea typeface="Arial"/>
+                <a:cs typeface="Arial"/>
+              </a:defRPr>
+            </a:pPr>
+            <a:r>
+              <a:rPr sz="2175" b="0">
+                <a:solidFill>
+                  <a:srgbClr val="F5F2E8"/>
                 </a:solidFill>
                 <a:latin typeface="Arial"/>
                 <a:ea typeface="Arial"/>
                 <a:cs typeface="Arial"/>
               </a:rPr>
               <a:t>Учитывает лаги и синергии</a:t>
-            </a:r>
-          </a:p>
-          <a:p xmlns:a="http://schemas.openxmlformats.org/drawingml/2006/main">
-            <a:pPr>
-              <a:defRPr sz="2100" b="0">
-                <a:solidFill>
-                  <a:srgbClr val="183B36"/>
-                </a:solidFill>
-                <a:latin typeface="Arial"/>
-                <a:ea typeface="Arial"/>
-                <a:cs typeface="Arial"/>
-              </a:defRPr>
-            </a:pPr>
-            <a:r>
-              <a:rPr sz="2100" b="0">
-                <a:solidFill>
-                  <a:srgbClr val="183B36"/>
-                </a:solidFill>
-                <a:latin typeface="Arial"/>
-                <a:ea typeface="Arial"/>
-                <a:cs typeface="Arial"/>
-              </a:rPr>
-              <a:t>Рассчитывает показатели и Score</a:t>
             </a:r>
           </a:p>
         </p:txBody>
@@ -3616,7 +3366,7 @@
           <p:cNvPr id="4" name="">
             <a:extLst xmlns:a="http://schemas.openxmlformats.org/drawingml/2006/main">
               <a:ext uri="{FF2B5EF4-FFF2-40B4-BE49-F238E27FC236}">
-                <a16:creationId xmlns:a16="http://schemas.microsoft.com/office/drawing/2014/main" id="{89AFFC80-CDA0-4EA4-A3D1-1066FB93CF87}"/>
+                <a16:creationId xmlns:a16="http://schemas.microsoft.com/office/drawing/2014/main" id="{6F23EE5D-1C08-4019-B1C8-8126848FB193}"/>
               </a:ext>
             </a:extLst>
           </p:cNvPr>
@@ -3627,8 +3377,8 @@
         </p:nvSpPr>
         <p:spPr>
           <a:xfrm xmlns:a="http://schemas.openxmlformats.org/drawingml/2006/main">
-            <a:off x="6667500" y="1800225"/>
-            <a:ext cx="4762500" cy="571500"/>
+            <a:off x="6791325" y="2143125"/>
+            <a:ext cx="4667250" cy="781050"/>
           </a:xfrm>
           <a:prstGeom xmlns:a="http://schemas.openxmlformats.org/drawingml/2006/main" prst="rect">
             <a:avLst/>
@@ -3645,25 +3395,25 @@
           <a:lstStyle xmlns:a="http://schemas.openxmlformats.org/drawingml/2006/main"/>
           <a:p xmlns:a="http://schemas.openxmlformats.org/drawingml/2006/main">
             <a:pPr>
-              <a:defRPr sz="2625" b="1">
-                <a:solidFill>
-                  <a:srgbClr val="194E42"/>
-                </a:solidFill>
-                <a:latin typeface="Arial"/>
-                <a:ea typeface="Arial"/>
-                <a:cs typeface="Arial"/>
-              </a:defRPr>
-            </a:pPr>
-            <a:r>
-              <a:rPr sz="2625" b="1">
-                <a:solidFill>
-                  <a:srgbClr val="194E42"/>
-                </a:solidFill>
-                <a:latin typeface="Arial"/>
-                <a:ea typeface="Arial"/>
-                <a:cs typeface="Arial"/>
-              </a:rPr>
-              <a:t>AI объясняет</a:t>
+              <a:defRPr sz="4350" b="1">
+                <a:solidFill>
+                  <a:srgbClr val="E8C77C"/>
+                </a:solidFill>
+                <a:latin typeface="Arial"/>
+                <a:ea typeface="Arial"/>
+                <a:cs typeface="Arial"/>
+              </a:defRPr>
+            </a:pPr>
+            <a:r>
+              <a:rPr sz="4350" b="1">
+                <a:solidFill>
+                  <a:srgbClr val="E8C77C"/>
+                </a:solidFill>
+                <a:latin typeface="Arial"/>
+                <a:ea typeface="Arial"/>
+                <a:cs typeface="Arial"/>
+              </a:rPr>
+              <a:t>AI</a:t>
             </a:r>
           </a:p>
         </p:txBody>
@@ -3673,7 +3423,7 @@
           <p:cNvPr id="5" name="">
             <a:extLst xmlns:a="http://schemas.openxmlformats.org/drawingml/2006/main">
               <a:ext uri="{FF2B5EF4-FFF2-40B4-BE49-F238E27FC236}">
-                <a16:creationId xmlns:a16="http://schemas.microsoft.com/office/drawing/2014/main" id="{FBC9E771-DFA2-4D62-9029-EC31DAB71936}"/>
+                <a16:creationId xmlns:a16="http://schemas.microsoft.com/office/drawing/2014/main" id="{390AFED3-7A2D-4CDA-A132-7EC60CC28739}"/>
               </a:ext>
             </a:extLst>
           </p:cNvPr>
@@ -3684,8 +3434,8 @@
         </p:nvSpPr>
         <p:spPr>
           <a:xfrm xmlns:a="http://schemas.openxmlformats.org/drawingml/2006/main">
-            <a:off x="6667500" y="2705100"/>
-            <a:ext cx="4762500" cy="1743075"/>
+            <a:off x="6791325" y="3295650"/>
+            <a:ext cx="4857750" cy="1562100"/>
           </a:xfrm>
           <a:prstGeom xmlns:a="http://schemas.openxmlformats.org/drawingml/2006/main" prst="rect">
             <a:avLst/>
@@ -3702,71 +3452,71 @@
           <a:lstStyle xmlns:a="http://schemas.openxmlformats.org/drawingml/2006/main"/>
           <a:p xmlns:a="http://schemas.openxmlformats.org/drawingml/2006/main">
             <a:pPr>
-              <a:defRPr sz="2100" b="0">
-                <a:solidFill>
-                  <a:srgbClr val="183B36"/>
-                </a:solidFill>
-                <a:latin typeface="Arial"/>
-                <a:ea typeface="Arial"/>
-                <a:cs typeface="Arial"/>
-              </a:defRPr>
-            </a:pPr>
-            <a:r>
-              <a:rPr sz="2100" b="0">
-                <a:solidFill>
-                  <a:srgbClr val="183B36"/>
-                </a:solidFill>
-                <a:latin typeface="Arial"/>
-                <a:ea typeface="Arial"/>
-                <a:cs typeface="Arial"/>
-              </a:rPr>
-              <a:t>Получает готовый расчёт</a:t>
-            </a:r>
-          </a:p>
-          <a:p xmlns:a="http://schemas.openxmlformats.org/drawingml/2006/main">
-            <a:pPr>
-              <a:defRPr sz="2100" b="0">
-                <a:solidFill>
-                  <a:srgbClr val="183B36"/>
-                </a:solidFill>
-                <a:latin typeface="Arial"/>
-                <a:ea typeface="Arial"/>
-                <a:cs typeface="Arial"/>
-              </a:defRPr>
-            </a:pPr>
-            <a:r>
-              <a:rPr sz="2100" b="0">
-                <a:solidFill>
-                  <a:srgbClr val="183B36"/>
-                </a:solidFill>
-                <a:latin typeface="Arial"/>
-                <a:ea typeface="Arial"/>
-                <a:cs typeface="Arial"/>
-              </a:rPr>
-              <a:t>Описывает компромиссы и риски</a:t>
-            </a:r>
-          </a:p>
-          <a:p xmlns:a="http://schemas.openxmlformats.org/drawingml/2006/main">
-            <a:pPr>
-              <a:defRPr sz="2100" b="0">
-                <a:solidFill>
-                  <a:srgbClr val="183B36"/>
-                </a:solidFill>
-                <a:latin typeface="Arial"/>
-                <a:ea typeface="Arial"/>
-                <a:cs typeface="Arial"/>
-              </a:defRPr>
-            </a:pPr>
-            <a:r>
-              <a:rPr sz="2100" b="0">
-                <a:solidFill>
-                  <a:srgbClr val="183B36"/>
-                </a:solidFill>
-                <a:latin typeface="Arial"/>
-                <a:ea typeface="Arial"/>
-                <a:cs typeface="Arial"/>
-              </a:rPr>
-              <a:t>Предлагает возможные реакции жителей</a:t>
+              <a:defRPr sz="2175" b="0">
+                <a:solidFill>
+                  <a:srgbClr val="F5F2E8"/>
+                </a:solidFill>
+                <a:latin typeface="Arial"/>
+                <a:ea typeface="Arial"/>
+                <a:cs typeface="Arial"/>
+              </a:defRPr>
+            </a:pPr>
+            <a:r>
+              <a:rPr sz="2175" b="0">
+                <a:solidFill>
+                  <a:srgbClr val="F5F2E8"/>
+                </a:solidFill>
+                <a:latin typeface="Arial"/>
+                <a:ea typeface="Arial"/>
+                <a:cs typeface="Arial"/>
+              </a:rPr>
+              <a:t>Объясняет готовый расчёт</a:t>
+            </a:r>
+          </a:p>
+          <a:p xmlns:a="http://schemas.openxmlformats.org/drawingml/2006/main">
+            <a:pPr>
+              <a:defRPr sz="2175" b="0">
+                <a:solidFill>
+                  <a:srgbClr val="F5F2E8"/>
+                </a:solidFill>
+                <a:latin typeface="Arial"/>
+                <a:ea typeface="Arial"/>
+                <a:cs typeface="Arial"/>
+              </a:defRPr>
+            </a:pPr>
+            <a:r>
+              <a:rPr sz="2175" b="0">
+                <a:solidFill>
+                  <a:srgbClr val="F5F2E8"/>
+                </a:solidFill>
+                <a:latin typeface="Arial"/>
+                <a:ea typeface="Arial"/>
+                <a:cs typeface="Arial"/>
+              </a:rPr>
+              <a:t>Описывает риски</a:t>
+            </a:r>
+          </a:p>
+          <a:p xmlns:a="http://schemas.openxmlformats.org/drawingml/2006/main">
+            <a:pPr>
+              <a:defRPr sz="2175" b="0">
+                <a:solidFill>
+                  <a:srgbClr val="F5F2E8"/>
+                </a:solidFill>
+                <a:latin typeface="Arial"/>
+                <a:ea typeface="Arial"/>
+                <a:cs typeface="Arial"/>
+              </a:defRPr>
+            </a:pPr>
+            <a:r>
+              <a:rPr sz="2175" b="0">
+                <a:solidFill>
+                  <a:srgbClr val="F5F2E8"/>
+                </a:solidFill>
+                <a:latin typeface="Arial"/>
+                <a:ea typeface="Arial"/>
+                <a:cs typeface="Arial"/>
+              </a:rPr>
+              <a:t>Обсуждает реакции жителей</a:t>
             </a:r>
           </a:p>
         </p:txBody>
@@ -3776,7 +3526,7 @@
           <p:cNvPr id="6" name="">
             <a:extLst xmlns:a="http://schemas.openxmlformats.org/drawingml/2006/main">
               <a:ext uri="{FF2B5EF4-FFF2-40B4-BE49-F238E27FC236}">
-                <a16:creationId xmlns:a16="http://schemas.microsoft.com/office/drawing/2014/main" id="{C9E0106C-3BBD-4032-9E4D-B03C43908D46}"/>
+                <a16:creationId xmlns:a16="http://schemas.microsoft.com/office/drawing/2014/main" id="{C26A018F-C030-40C0-BEBE-238B8B5154CF}"/>
               </a:ext>
             </a:extLst>
           </p:cNvPr>
@@ -3787,8 +3537,8 @@
         </p:nvSpPr>
         <p:spPr>
           <a:xfrm xmlns:a="http://schemas.openxmlformats.org/drawingml/2006/main">
-            <a:off x="685800" y="4953000"/>
-            <a:ext cx="10858500" cy="600075"/>
+            <a:off x="695325" y="5514975"/>
+            <a:ext cx="10858500" cy="495300"/>
           </a:xfrm>
           <a:prstGeom xmlns:a="http://schemas.openxmlformats.org/drawingml/2006/main" prst="rect">
             <a:avLst/>
@@ -3805,19 +3555,19 @@
           <a:lstStyle xmlns:a="http://schemas.openxmlformats.org/drawingml/2006/main"/>
           <a:p xmlns:a="http://schemas.openxmlformats.org/drawingml/2006/main">
             <a:pPr>
-              <a:defRPr sz="2175" b="1">
-                <a:solidFill>
-                  <a:srgbClr val="183B36"/>
-                </a:solidFill>
-                <a:latin typeface="Arial"/>
-                <a:ea typeface="Arial"/>
-                <a:cs typeface="Arial"/>
-              </a:defRPr>
-            </a:pPr>
-            <a:r>
-              <a:rPr sz="2175" b="1">
-                <a:solidFill>
-                  <a:srgbClr val="183B36"/>
+              <a:defRPr sz="2100" b="1">
+                <a:solidFill>
+                  <a:srgbClr val="F5F2E8"/>
+                </a:solidFill>
+                <a:latin typeface="Arial"/>
+                <a:ea typeface="Arial"/>
+                <a:cs typeface="Arial"/>
+              </a:defRPr>
+            </a:pPr>
+            <a:r>
+              <a:rPr sz="2100" b="1">
+                <a:solidFill>
+                  <a:srgbClr val="F5F2E8"/>
                 </a:solidFill>
                 <a:latin typeface="Arial"/>
                 <a:ea typeface="Arial"/>
@@ -3833,7 +3583,7 @@
           <p:cNvPr id="7" name="">
             <a:extLst xmlns:a="http://schemas.openxmlformats.org/drawingml/2006/main">
               <a:ext uri="{FF2B5EF4-FFF2-40B4-BE49-F238E27FC236}">
-                <a16:creationId xmlns:a16="http://schemas.microsoft.com/office/drawing/2014/main" id="{14404958-CD56-4D60-875A-AB3917ADFF31}"/>
+                <a16:creationId xmlns:a16="http://schemas.microsoft.com/office/drawing/2014/main" id="{6ADED42B-63C6-4EA3-A798-98D2AB8131E3}"/>
               </a:ext>
             </a:extLst>
           </p:cNvPr>
@@ -3844,8 +3594,8 @@
         </p:nvSpPr>
         <p:spPr>
           <a:xfrm xmlns:a="http://schemas.openxmlformats.org/drawingml/2006/main">
-            <a:off x="685800" y="5648325"/>
-            <a:ext cx="10763250" cy="714375"/>
+            <a:off x="695325" y="6172200"/>
+            <a:ext cx="10763250" cy="381000"/>
           </a:xfrm>
           <a:prstGeom xmlns:a="http://schemas.openxmlformats.org/drawingml/2006/main" prst="rect">
             <a:avLst/>
@@ -3862,19 +3612,19 @@
           <a:lstStyle xmlns:a="http://schemas.openxmlformats.org/drawingml/2006/main"/>
           <a:p xmlns:a="http://schemas.openxmlformats.org/drawingml/2006/main">
             <a:pPr>
-              <a:defRPr sz="1650" b="0">
-                <a:solidFill>
-                  <a:srgbClr val="62736B"/>
-                </a:solidFill>
-                <a:latin typeface="Arial"/>
-                <a:ea typeface="Arial"/>
-                <a:cs typeface="Arial"/>
-              </a:defRPr>
-            </a:pPr>
-            <a:r>
-              <a:rPr sz="1650" b="0">
-                <a:solidFill>
-                  <a:srgbClr val="62736B"/>
+              <a:defRPr sz="1575" b="0">
+                <a:solidFill>
+                  <a:srgbClr val="BED2AE"/>
+                </a:solidFill>
+                <a:latin typeface="Arial"/>
+                <a:ea typeface="Arial"/>
+                <a:cs typeface="Arial"/>
+              </a:defRPr>
+            </a:pPr>
+            <a:r>
+              <a:rPr sz="1575" b="0">
+                <a:solidFill>
+                  <a:srgbClr val="BED2AE"/>
                 </a:solidFill>
                 <a:latin typeface="Arial"/>
                 <a:ea typeface="Arial"/>
@@ -3888,7 +3638,7 @@
     </p:spTree>
     <p:extLst>
       <p:ext uri="{BB962C8B-B14F-4D97-AF65-F5344CB8AC3E}">
-        <p14:creationId xmlns:p14="http://schemas.microsoft.com/office/powerpoint/2010/main" val="344803361"/>
+        <p14:creationId xmlns:p14="http://schemas.microsoft.com/office/powerpoint/2010/main" val="1740602614"/>
       </p:ext>
     </p:extLst>
   </p:cSld>
@@ -3916,10 +3666,10 @@
       </p:grpSpPr>
       <p:sp>
         <p:nvSpPr>
-          <p:cNvPr id="6" name="">
+          <p:cNvPr id="10" name="">
             <a:extLst xmlns:a="http://schemas.openxmlformats.org/drawingml/2006/main">
               <a:ext uri="{FF2B5EF4-FFF2-40B4-BE49-F238E27FC236}">
-                <a16:creationId xmlns:a16="http://schemas.microsoft.com/office/drawing/2014/main" id="{D52E01D3-574A-4BB1-BCBB-27AFCD49994C}"/>
+                <a16:creationId xmlns:a16="http://schemas.microsoft.com/office/drawing/2014/main" id="{11C32D48-9D36-44D3-AADA-11084730C156}"/>
               </a:ext>
             </a:extLst>
           </p:cNvPr>
@@ -3966,7 +3716,7 @@
                 <a:ea typeface="Georgia"/>
                 <a:cs typeface="Georgia"/>
               </a:rPr>
-              <a:t>Район меняет результат при том же бюджете</a:t>
+              <a:t>Один перенос — минус 1,25 балла</a:t>
             </a:r>
           </a:p>
         </p:txBody>
@@ -3976,7 +3726,7 @@
           <p:cNvPr id="2" name="">
             <a:extLst xmlns:a="http://schemas.openxmlformats.org/drawingml/2006/main">
               <a:ext uri="{FF2B5EF4-FFF2-40B4-BE49-F238E27FC236}">
-                <a16:creationId xmlns:a16="http://schemas.microsoft.com/office/drawing/2014/main" id="{2428AAFA-4CD6-4050-AEF0-5E460CE60585}"/>
+                <a16:creationId xmlns:a16="http://schemas.microsoft.com/office/drawing/2014/main" id="{085BD229-32BC-45CA-898F-CD6666417FFF}"/>
               </a:ext>
             </a:extLst>
           </p:cNvPr>
@@ -3987,8 +3737,8 @@
         </p:nvSpPr>
         <p:spPr>
           <a:xfrm xmlns:a="http://schemas.openxmlformats.org/drawingml/2006/main">
-            <a:off x="666750" y="1438275"/>
-            <a:ext cx="10858500" cy="647700"/>
+            <a:off x="695325" y="1676400"/>
+            <a:ext cx="4381500" cy="352425"/>
           </a:xfrm>
           <a:prstGeom xmlns:a="http://schemas.openxmlformats.org/drawingml/2006/main" prst="rect">
             <a:avLst/>
@@ -4005,7 +3755,7 @@
           <a:lstStyle xmlns:a="http://schemas.openxmlformats.org/drawingml/2006/main"/>
           <a:p xmlns:a="http://schemas.openxmlformats.org/drawingml/2006/main">
             <a:pPr>
-              <a:defRPr sz="2250" b="0">
+              <a:defRPr sz="1575" b="1">
                 <a:solidFill>
                   <a:srgbClr val="62736B"/>
                 </a:solidFill>
@@ -4015,7 +3765,7 @@
               </a:defRPr>
             </a:pPr>
             <a:r>
-              <a:rPr sz="2250" b="0">
+              <a:rPr sz="1575" b="1">
                 <a:solidFill>
                   <a:srgbClr val="62736B"/>
                 </a:solidFill>
@@ -4023,39 +3773,323 @@
                 <a:ea typeface="Arial"/>
                 <a:cs typeface="Arial"/>
               </a:rPr>
-              <a:t>A: школа и детсад в Нуре. B: та же мера в Есиле.</a:t>
+              <a:t>СЦЕНАРИЙ A</a:t>
+            </a:r>
+          </a:p>
+        </p:txBody>
+      </p:sp>
+      <p:sp>
+        <p:nvSpPr>
+          <p:cNvPr id="3" name="">
+            <a:extLst xmlns:a="http://schemas.openxmlformats.org/drawingml/2006/main">
+              <a:ext uri="{FF2B5EF4-FFF2-40B4-BE49-F238E27FC236}">
+                <a16:creationId xmlns:a16="http://schemas.microsoft.com/office/drawing/2014/main" id="{A425E088-4E55-490A-A314-F66E6BEF61A9}"/>
+              </a:ext>
+            </a:extLst>
+          </p:cNvPr>
+          <p:cNvSpPr>
+            <a:spLocks xmlns:a="http://schemas.openxmlformats.org/drawingml/2006/main" noGrp="1"/>
+          </p:cNvSpPr>
+          <p:nvPr/>
+        </p:nvSpPr>
+        <p:spPr>
+          <a:xfrm xmlns:a="http://schemas.openxmlformats.org/drawingml/2006/main">
+            <a:off x="6696075" y="1676400"/>
+            <a:ext cx="4381500" cy="352425"/>
+          </a:xfrm>
+          <a:prstGeom xmlns:a="http://schemas.openxmlformats.org/drawingml/2006/main" prst="rect">
+            <a:avLst/>
+          </a:prstGeom>
+          <a:noFill xmlns:a="http://schemas.openxmlformats.org/drawingml/2006/main"/>
+          <a:ln xmlns:a="http://schemas.openxmlformats.org/drawingml/2006/main" w="0">
+            <a:noFill/>
+          </a:ln>
+        </p:spPr>
+        <p:txBody>
+          <a:bodyPr xmlns:a="http://schemas.openxmlformats.org/drawingml/2006/main">
+            <a:noAutofit/>
+          </a:bodyPr>
+          <a:lstStyle xmlns:a="http://schemas.openxmlformats.org/drawingml/2006/main"/>
+          <a:p xmlns:a="http://schemas.openxmlformats.org/drawingml/2006/main">
+            <a:pPr>
+              <a:defRPr sz="1575" b="1">
+                <a:solidFill>
+                  <a:srgbClr val="62736B"/>
+                </a:solidFill>
+                <a:latin typeface="Arial"/>
+                <a:ea typeface="Arial"/>
+                <a:cs typeface="Arial"/>
+              </a:defRPr>
+            </a:pPr>
+            <a:r>
+              <a:rPr sz="1575" b="1">
+                <a:solidFill>
+                  <a:srgbClr val="62736B"/>
+                </a:solidFill>
+                <a:latin typeface="Arial"/>
+                <a:ea typeface="Arial"/>
+                <a:cs typeface="Arial"/>
+              </a:rPr>
+              <a:t>СЦЕНАРИЙ B</a:t>
+            </a:r>
+          </a:p>
+        </p:txBody>
+      </p:sp>
+      <p:sp>
+        <p:nvSpPr>
+          <p:cNvPr id="4" name="">
+            <a:extLst xmlns:a="http://schemas.openxmlformats.org/drawingml/2006/main">
+              <a:ext uri="{FF2B5EF4-FFF2-40B4-BE49-F238E27FC236}">
+                <a16:creationId xmlns:a16="http://schemas.microsoft.com/office/drawing/2014/main" id="{BADD8960-71F6-44FE-BEA6-F9D96477B320}"/>
+              </a:ext>
+            </a:extLst>
+          </p:cNvPr>
+          <p:cNvSpPr>
+            <a:spLocks xmlns:a="http://schemas.openxmlformats.org/drawingml/2006/main" noGrp="1"/>
+          </p:cNvSpPr>
+          <p:nvPr/>
+        </p:nvSpPr>
+        <p:spPr>
+          <a:xfrm xmlns:a="http://schemas.openxmlformats.org/drawingml/2006/main">
+            <a:off x="638175" y="2095500"/>
+            <a:ext cx="5143500" cy="1057275"/>
+          </a:xfrm>
+          <a:prstGeom xmlns:a="http://schemas.openxmlformats.org/drawingml/2006/main" prst="rect">
+            <a:avLst/>
+          </a:prstGeom>
+          <a:noFill xmlns:a="http://schemas.openxmlformats.org/drawingml/2006/main"/>
+          <a:ln xmlns:a="http://schemas.openxmlformats.org/drawingml/2006/main" w="0">
+            <a:noFill/>
+          </a:ln>
+        </p:spPr>
+        <p:txBody>
+          <a:bodyPr xmlns:a="http://schemas.openxmlformats.org/drawingml/2006/main">
+            <a:noAutofit/>
+          </a:bodyPr>
+          <a:lstStyle xmlns:a="http://schemas.openxmlformats.org/drawingml/2006/main"/>
+          <a:p xmlns:a="http://schemas.openxmlformats.org/drawingml/2006/main">
+            <a:pPr>
+              <a:defRPr sz="6450" b="1">
+                <a:solidFill>
+                  <a:srgbClr val="194E42"/>
+                </a:solidFill>
+                <a:latin typeface="Arial"/>
+                <a:ea typeface="Arial"/>
+                <a:cs typeface="Arial"/>
+              </a:defRPr>
+            </a:pPr>
+            <a:r>
+              <a:rPr sz="6450" b="1">
+                <a:solidFill>
+                  <a:srgbClr val="194E42"/>
+                </a:solidFill>
+                <a:latin typeface="Arial"/>
+                <a:ea typeface="Arial"/>
+                <a:cs typeface="Arial"/>
+              </a:rPr>
+              <a:t>56,54</a:t>
+            </a:r>
+          </a:p>
+        </p:txBody>
+      </p:sp>
+      <p:sp>
+        <p:nvSpPr>
+          <p:cNvPr id="5" name="">
+            <a:extLst xmlns:a="http://schemas.openxmlformats.org/drawingml/2006/main">
+              <a:ext uri="{FF2B5EF4-FFF2-40B4-BE49-F238E27FC236}">
+                <a16:creationId xmlns:a16="http://schemas.microsoft.com/office/drawing/2014/main" id="{A380A38C-7676-4850-80DC-DA71A2AFE8E4}"/>
+              </a:ext>
+            </a:extLst>
+          </p:cNvPr>
+          <p:cNvSpPr>
+            <a:spLocks xmlns:a="http://schemas.openxmlformats.org/drawingml/2006/main" noGrp="1"/>
+          </p:cNvSpPr>
+          <p:nvPr/>
+        </p:nvSpPr>
+        <p:spPr>
+          <a:xfrm xmlns:a="http://schemas.openxmlformats.org/drawingml/2006/main">
+            <a:off x="6638925" y="2095500"/>
+            <a:ext cx="5143500" cy="1057275"/>
+          </a:xfrm>
+          <a:prstGeom xmlns:a="http://schemas.openxmlformats.org/drawingml/2006/main" prst="rect">
+            <a:avLst/>
+          </a:prstGeom>
+          <a:noFill xmlns:a="http://schemas.openxmlformats.org/drawingml/2006/main"/>
+          <a:ln xmlns:a="http://schemas.openxmlformats.org/drawingml/2006/main" w="0">
+            <a:noFill/>
+          </a:ln>
+        </p:spPr>
+        <p:txBody>
+          <a:bodyPr xmlns:a="http://schemas.openxmlformats.org/drawingml/2006/main">
+            <a:noAutofit/>
+          </a:bodyPr>
+          <a:lstStyle xmlns:a="http://schemas.openxmlformats.org/drawingml/2006/main"/>
+          <a:p xmlns:a="http://schemas.openxmlformats.org/drawingml/2006/main">
+            <a:pPr>
+              <a:defRPr sz="6450" b="1">
+                <a:solidFill>
+                  <a:srgbClr val="AA7E32"/>
+                </a:solidFill>
+                <a:latin typeface="Arial"/>
+                <a:ea typeface="Arial"/>
+                <a:cs typeface="Arial"/>
+              </a:defRPr>
+            </a:pPr>
+            <a:r>
+              <a:rPr sz="6450" b="1">
+                <a:solidFill>
+                  <a:srgbClr val="AA7E32"/>
+                </a:solidFill>
+                <a:latin typeface="Arial"/>
+                <a:ea typeface="Arial"/>
+                <a:cs typeface="Arial"/>
+              </a:rPr>
+              <a:t>55,30</a:t>
+            </a:r>
+          </a:p>
+        </p:txBody>
+      </p:sp>
+      <p:sp>
+        <p:nvSpPr>
+          <p:cNvPr id="6" name="">
+            <a:extLst xmlns:a="http://schemas.openxmlformats.org/drawingml/2006/main">
+              <a:ext uri="{FF2B5EF4-FFF2-40B4-BE49-F238E27FC236}">
+                <a16:creationId xmlns:a16="http://schemas.microsoft.com/office/drawing/2014/main" id="{588309FC-6B83-49B9-91B9-EAAFABC46A94}"/>
+              </a:ext>
+            </a:extLst>
+          </p:cNvPr>
+          <p:cNvSpPr>
+            <a:spLocks xmlns:a="http://schemas.openxmlformats.org/drawingml/2006/main" noGrp="1"/>
+          </p:cNvSpPr>
+          <p:nvPr/>
+        </p:nvSpPr>
+        <p:spPr>
+          <a:xfrm xmlns:a="http://schemas.openxmlformats.org/drawingml/2006/main">
+            <a:off x="695325" y="3209925"/>
+            <a:ext cx="5143500" cy="447675"/>
+          </a:xfrm>
+          <a:prstGeom xmlns:a="http://schemas.openxmlformats.org/drawingml/2006/main" prst="rect">
+            <a:avLst/>
+          </a:prstGeom>
+          <a:noFill xmlns:a="http://schemas.openxmlformats.org/drawingml/2006/main"/>
+          <a:ln xmlns:a="http://schemas.openxmlformats.org/drawingml/2006/main" w="0">
+            <a:noFill/>
+          </a:ln>
+        </p:spPr>
+        <p:txBody>
+          <a:bodyPr xmlns:a="http://schemas.openxmlformats.org/drawingml/2006/main">
+            <a:noAutofit/>
+          </a:bodyPr>
+          <a:lstStyle xmlns:a="http://schemas.openxmlformats.org/drawingml/2006/main"/>
+          <a:p xmlns:a="http://schemas.openxmlformats.org/drawingml/2006/main">
+            <a:pPr>
+              <a:defRPr sz="2100" b="0">
+                <a:solidFill>
+                  <a:srgbClr val="183B36"/>
+                </a:solidFill>
+                <a:latin typeface="Arial"/>
+                <a:ea typeface="Arial"/>
+                <a:cs typeface="Arial"/>
+              </a:defRPr>
+            </a:pPr>
+            <a:r>
+              <a:rPr sz="2100" b="0">
+                <a:solidFill>
+                  <a:srgbClr val="183B36"/>
+                </a:solidFill>
+                <a:latin typeface="Arial"/>
+                <a:ea typeface="Arial"/>
+                <a:cs typeface="Arial"/>
+              </a:rPr>
+              <a:t>Школа и детсад в Нуре</a:t>
+            </a:r>
+          </a:p>
+        </p:txBody>
+      </p:sp>
+      <p:sp>
+        <p:nvSpPr>
+          <p:cNvPr id="7" name="">
+            <a:extLst xmlns:a="http://schemas.openxmlformats.org/drawingml/2006/main">
+              <a:ext uri="{FF2B5EF4-FFF2-40B4-BE49-F238E27FC236}">
+                <a16:creationId xmlns:a16="http://schemas.microsoft.com/office/drawing/2014/main" id="{AA21DCE4-EE91-4460-B11F-8E00156A7EC1}"/>
+              </a:ext>
+            </a:extLst>
+          </p:cNvPr>
+          <p:cNvSpPr>
+            <a:spLocks xmlns:a="http://schemas.openxmlformats.org/drawingml/2006/main" noGrp="1"/>
+          </p:cNvSpPr>
+          <p:nvPr/>
+        </p:nvSpPr>
+        <p:spPr>
+          <a:xfrm xmlns:a="http://schemas.openxmlformats.org/drawingml/2006/main">
+            <a:off x="6696075" y="3209925"/>
+            <a:ext cx="4953000" cy="447675"/>
+          </a:xfrm>
+          <a:prstGeom xmlns:a="http://schemas.openxmlformats.org/drawingml/2006/main" prst="rect">
+            <a:avLst/>
+          </a:prstGeom>
+          <a:noFill xmlns:a="http://schemas.openxmlformats.org/drawingml/2006/main"/>
+          <a:ln xmlns:a="http://schemas.openxmlformats.org/drawingml/2006/main" w="0">
+            <a:noFill/>
+          </a:ln>
+        </p:spPr>
+        <p:txBody>
+          <a:bodyPr xmlns:a="http://schemas.openxmlformats.org/drawingml/2006/main">
+            <a:noAutofit/>
+          </a:bodyPr>
+          <a:lstStyle xmlns:a="http://schemas.openxmlformats.org/drawingml/2006/main"/>
+          <a:p xmlns:a="http://schemas.openxmlformats.org/drawingml/2006/main">
+            <a:pPr>
+              <a:defRPr sz="2100" b="0">
+                <a:solidFill>
+                  <a:srgbClr val="183B36"/>
+                </a:solidFill>
+                <a:latin typeface="Arial"/>
+                <a:ea typeface="Arial"/>
+                <a:cs typeface="Arial"/>
+              </a:defRPr>
+            </a:pPr>
+            <a:r>
+              <a:rPr sz="2100" b="0">
+                <a:solidFill>
+                  <a:srgbClr val="183B36"/>
+                </a:solidFill>
+                <a:latin typeface="Arial"/>
+                <a:ea typeface="Arial"/>
+                <a:cs typeface="Arial"/>
+              </a:rPr>
+              <a:t>Та же мера в Есиле</a:t>
             </a:r>
           </a:p>
         </p:txBody>
       </p:sp>
       <p:graphicFrame>
         <p:nvGraphicFramePr>
-          <p:cNvPr id="8" name=""/>
+          <p:cNvPr id="17" name=""/>
           <p:cNvGraphicFramePr/>
           <p:nvPr/>
         </p:nvGraphicFramePr>
         <p:xfrm>
-          <a:off xmlns:a="http://schemas.openxmlformats.org/drawingml/2006/main" x="666750" y="2400300"/>
-          <a:ext xmlns:a="http://schemas.openxmlformats.org/drawingml/2006/main" cx="10820400" cy="2743200"/>
+          <a:off xmlns:a="http://schemas.openxmlformats.org/drawingml/2006/main" x="685800" y="3971925"/>
+          <a:ext xmlns:a="http://schemas.openxmlformats.org/drawingml/2006/main" cx="10820400" cy="1943100"/>
         </p:xfrm>
         <a:graphic xmlns:a="http://schemas.openxmlformats.org/drawingml/2006/main">
           <a:graphicData uri="http://schemas.openxmlformats.org/drawingml/2006/table">
             <a:tbl>
               <a:tblPr/>
               <a:tblGrid>
-                <a:gridCol w="4191000"/>
-                <a:gridCol w="2057400"/>
-                <a:gridCol w="2286000"/>
-                <a:gridCol w="2286000"/>
+                <a:gridCol w="5181600"/>
+                <a:gridCol w="2819400"/>
+                <a:gridCol w="2819400"/>
               </a:tblGrid>
-              <a:tr h="685800">
+              <a:tr h="485775">
                 <a:tc>
                   <a:txBody>
                     <a:bodyPr/>
                     <a:lstStyle/>
                     <a:p>
                       <a:r>
-                        <a:rPr sz="1950" b="1">
+                        <a:rPr sz="1800" b="1">
                           <a:solidFill>
                             <a:srgbClr val="FFFEF9"/>
                           </a:solidFill>
@@ -4079,7 +4113,7 @@
                     <a:lstStyle/>
                     <a:p>
                       <a:r>
-                        <a:rPr sz="1950" b="1">
+                        <a:rPr sz="1800" b="1">
                           <a:solidFill>
                             <a:srgbClr val="FFFEF9"/>
                           </a:solidFill>
@@ -4087,7 +4121,7 @@
                           <a:ea typeface="Arial"/>
                           <a:cs typeface="Arial"/>
                         </a:rPr>
-                        <a:t>Исходно</a:t>
+                        <a:t>A</a:t>
                       </a:r>
                     </a:p>
                   </a:txBody>
@@ -4103,7 +4137,7 @@
                     <a:lstStyle/>
                     <a:p>
                       <a:r>
-                        <a:rPr sz="1950" b="1">
+                        <a:rPr sz="1800" b="1">
                           <a:solidFill>
                             <a:srgbClr val="FFFEF9"/>
                           </a:solidFill>
@@ -4111,31 +4145,7 @@
                           <a:ea typeface="Arial"/>
                           <a:cs typeface="Arial"/>
                         </a:rPr>
-                        <a:t>Сценарий A</a:t>
-                      </a:r>
-                    </a:p>
-                  </a:txBody>
-                  <a:tcPr marL="91440" marR="91440" marT="45720" marB="45720">
-                    <a:solidFill>
-                      <a:srgbClr val="194E42"/>
-                    </a:solidFill>
-                  </a:tcPr>
-                </a:tc>
-                <a:tc>
-                  <a:txBody>
-                    <a:bodyPr/>
-                    <a:lstStyle/>
-                    <a:p>
-                      <a:r>
-                        <a:rPr sz="1950" b="1">
-                          <a:solidFill>
-                            <a:srgbClr val="FFFEF9"/>
-                          </a:solidFill>
-                          <a:latin typeface="Arial"/>
-                          <a:ea typeface="Arial"/>
-                          <a:cs typeface="Arial"/>
-                        </a:rPr>
-                        <a:t>Сценарий B</a:t>
+                        <a:t>B</a:t>
                       </a:r>
                     </a:p>
                   </a:txBody>
@@ -4146,14 +4156,88 @@
                   </a:tcPr>
                 </a:tc>
               </a:tr>
-              <a:tr h="685800">
+              <a:tr h="485775">
                 <a:tc>
                   <a:txBody>
                     <a:bodyPr/>
                     <a:lstStyle/>
                     <a:p>
                       <a:r>
-                        <a:rPr sz="2100" b="0">
+                        <a:rPr sz="1800" b="0">
+                          <a:solidFill>
+                            <a:srgbClr val="183B36"/>
+                          </a:solidFill>
+                          <a:latin typeface="Arial"/>
+                          <a:ea typeface="Arial"/>
+                          <a:cs typeface="Arial"/>
+                        </a:rPr>
+                        <a:t>Точный Score</a:t>
+                      </a:r>
+                    </a:p>
+                  </a:txBody>
+                  <a:tcPr marL="91440" marR="91440" marT="45720" marB="45720">
+                    <a:solidFill>
+                      <a:srgbClr val="FFFEF9"/>
+                    </a:solidFill>
+                  </a:tcPr>
+                </a:tc>
+                <a:tc>
+                  <a:txBody>
+                    <a:bodyPr/>
+                    <a:lstStyle/>
+                    <a:p>
+                      <a:r>
+                        <a:rPr sz="1800" b="0">
+                          <a:solidFill>
+                            <a:srgbClr val="183B36"/>
+                          </a:solidFill>
+                          <a:latin typeface="Arial"/>
+                          <a:ea typeface="Arial"/>
+                          <a:cs typeface="Arial"/>
+                        </a:rPr>
+                        <a:t>56,54307</a:t>
+                      </a:r>
+                    </a:p>
+                  </a:txBody>
+                  <a:tcPr marL="91440" marR="91440" marT="45720" marB="45720">
+                    <a:solidFill>
+                      <a:srgbClr val="FFFEF9"/>
+                    </a:solidFill>
+                  </a:tcPr>
+                </a:tc>
+                <a:tc>
+                  <a:txBody>
+                    <a:bodyPr/>
+                    <a:lstStyle/>
+                    <a:p>
+                      <a:r>
+                        <a:rPr sz="1800" b="0">
+                          <a:solidFill>
+                            <a:srgbClr val="183B36"/>
+                          </a:solidFill>
+                          <a:latin typeface="Arial"/>
+                          <a:ea typeface="Arial"/>
+                          <a:cs typeface="Arial"/>
+                        </a:rPr>
+                        <a:t>55,29777</a:t>
+                      </a:r>
+                    </a:p>
+                  </a:txBody>
+                  <a:tcPr marL="91440" marR="91440" marT="45720" marB="45720">
+                    <a:solidFill>
+                      <a:srgbClr val="FFFEF9"/>
+                    </a:solidFill>
+                  </a:tcPr>
+                </a:tc>
+              </a:tr>
+              <a:tr h="485775">
+                <a:tc>
+                  <a:txBody>
+                    <a:bodyPr/>
+                    <a:lstStyle/>
+                    <a:p>
+                      <a:r>
+                        <a:rPr sz="1800" b="0">
                           <a:solidFill>
                             <a:srgbClr val="183B36"/>
                           </a:solidFill>
@@ -4177,7 +4261,81 @@
                     <a:lstStyle/>
                     <a:p>
                       <a:r>
-                        <a:rPr sz="2100" b="0">
+                        <a:rPr sz="1800" b="0">
+                          <a:solidFill>
+                            <a:srgbClr val="183B36"/>
+                          </a:solidFill>
+                          <a:latin typeface="Arial"/>
+                          <a:ea typeface="Arial"/>
+                          <a:cs typeface="Arial"/>
+                        </a:rPr>
+                        <a:t>95</a:t>
+                      </a:r>
+                    </a:p>
+                  </a:txBody>
+                  <a:tcPr marL="91440" marR="91440" marT="45720" marB="45720">
+                    <a:solidFill>
+                      <a:srgbClr val="FFFEF9"/>
+                    </a:solidFill>
+                  </a:tcPr>
+                </a:tc>
+                <a:tc>
+                  <a:txBody>
+                    <a:bodyPr/>
+                    <a:lstStyle/>
+                    <a:p>
+                      <a:r>
+                        <a:rPr sz="1800" b="0">
+                          <a:solidFill>
+                            <a:srgbClr val="183B36"/>
+                          </a:solidFill>
+                          <a:latin typeface="Arial"/>
+                          <a:ea typeface="Arial"/>
+                          <a:cs typeface="Arial"/>
+                        </a:rPr>
+                        <a:t>95</a:t>
+                      </a:r>
+                    </a:p>
+                  </a:txBody>
+                  <a:tcPr marL="91440" marR="91440" marT="45720" marB="45720">
+                    <a:solidFill>
+                      <a:srgbClr val="FFFEF9"/>
+                    </a:solidFill>
+                  </a:tcPr>
+                </a:tc>
+              </a:tr>
+              <a:tr h="485775">
+                <a:tc>
+                  <a:txBody>
+                    <a:bodyPr/>
+                    <a:lstStyle/>
+                    <a:p>
+                      <a:r>
+                        <a:rPr sz="1800" b="0">
+                          <a:solidFill>
+                            <a:srgbClr val="183B36"/>
+                          </a:solidFill>
+                          <a:latin typeface="Arial"/>
+                          <a:ea typeface="Arial"/>
+                          <a:cs typeface="Arial"/>
+                        </a:rPr>
+                        <a:t>Показателей ниже 40</a:t>
+                      </a:r>
+                    </a:p>
+                  </a:txBody>
+                  <a:tcPr marL="91440" marR="91440" marT="45720" marB="45720">
+                    <a:solidFill>
+                      <a:srgbClr val="FFFEF9"/>
+                    </a:solidFill>
+                  </a:tcPr>
+                </a:tc>
+                <a:tc>
+                  <a:txBody>
+                    <a:bodyPr/>
+                    <a:lstStyle/>
+                    <a:p>
+                      <a:r>
+                        <a:rPr sz="1800" b="0">
                           <a:solidFill>
                             <a:srgbClr val="183B36"/>
                           </a:solidFill>
@@ -4201,227 +4359,7 @@
                     <a:lstStyle/>
                     <a:p>
                       <a:r>
-                        <a:rPr sz="2100" b="0">
-                          <a:solidFill>
-                            <a:srgbClr val="183B36"/>
-                          </a:solidFill>
-                          <a:latin typeface="Arial"/>
-                          <a:ea typeface="Arial"/>
-                          <a:cs typeface="Arial"/>
-                        </a:rPr>
-                        <a:t>95</a:t>
-                      </a:r>
-                    </a:p>
-                  </a:txBody>
-                  <a:tcPr marL="91440" marR="91440" marT="45720" marB="45720">
-                    <a:solidFill>
-                      <a:srgbClr val="FFFEF9"/>
-                    </a:solidFill>
-                  </a:tcPr>
-                </a:tc>
-                <a:tc>
-                  <a:txBody>
-                    <a:bodyPr/>
-                    <a:lstStyle/>
-                    <a:p>
-                      <a:r>
-                        <a:rPr sz="2100" b="0">
-                          <a:solidFill>
-                            <a:srgbClr val="183B36"/>
-                          </a:solidFill>
-                          <a:latin typeface="Arial"/>
-                          <a:ea typeface="Arial"/>
-                          <a:cs typeface="Arial"/>
-                        </a:rPr>
-                        <a:t>95</a:t>
-                      </a:r>
-                    </a:p>
-                  </a:txBody>
-                  <a:tcPr marL="91440" marR="91440" marT="45720" marB="45720">
-                    <a:solidFill>
-                      <a:srgbClr val="FFFEF9"/>
-                    </a:solidFill>
-                  </a:tcPr>
-                </a:tc>
-              </a:tr>
-              <a:tr h="685800">
-                <a:tc>
-                  <a:txBody>
-                    <a:bodyPr/>
-                    <a:lstStyle/>
-                    <a:p>
-                      <a:r>
-                        <a:rPr sz="2100" b="1">
-                          <a:solidFill>
-                            <a:srgbClr val="183B36"/>
-                          </a:solidFill>
-                          <a:latin typeface="Arial"/>
-                          <a:ea typeface="Arial"/>
-                          <a:cs typeface="Arial"/>
-                        </a:rPr>
-                        <a:t>Score</a:t>
-                      </a:r>
-                    </a:p>
-                  </a:txBody>
-                  <a:tcPr marL="91440" marR="91440" marT="45720" marB="45720">
-                    <a:solidFill>
-                      <a:srgbClr val="E7EDDF"/>
-                    </a:solidFill>
-                  </a:tcPr>
-                </a:tc>
-                <a:tc>
-                  <a:txBody>
-                    <a:bodyPr/>
-                    <a:lstStyle/>
-                    <a:p>
-                      <a:r>
-                        <a:rPr sz="2100" b="1">
-                          <a:solidFill>
-                            <a:srgbClr val="183B36"/>
-                          </a:solidFill>
-                          <a:latin typeface="Arial"/>
-                          <a:ea typeface="Arial"/>
-                          <a:cs typeface="Arial"/>
-                        </a:rPr>
-                        <a:t>52,55768</a:t>
-                      </a:r>
-                    </a:p>
-                  </a:txBody>
-                  <a:tcPr marL="91440" marR="91440" marT="45720" marB="45720">
-                    <a:solidFill>
-                      <a:srgbClr val="E7EDDF"/>
-                    </a:solidFill>
-                  </a:tcPr>
-                </a:tc>
-                <a:tc>
-                  <a:txBody>
-                    <a:bodyPr/>
-                    <a:lstStyle/>
-                    <a:p>
-                      <a:r>
-                        <a:rPr sz="2100" b="1">
-                          <a:solidFill>
-                            <a:srgbClr val="183B36"/>
-                          </a:solidFill>
-                          <a:latin typeface="Arial"/>
-                          <a:ea typeface="Arial"/>
-                          <a:cs typeface="Arial"/>
-                        </a:rPr>
-                        <a:t>56,54307</a:t>
-                      </a:r>
-                    </a:p>
-                  </a:txBody>
-                  <a:tcPr marL="91440" marR="91440" marT="45720" marB="45720">
-                    <a:solidFill>
-                      <a:srgbClr val="E7EDDF"/>
-                    </a:solidFill>
-                  </a:tcPr>
-                </a:tc>
-                <a:tc>
-                  <a:txBody>
-                    <a:bodyPr/>
-                    <a:lstStyle/>
-                    <a:p>
-                      <a:r>
-                        <a:rPr sz="2100" b="1">
-                          <a:solidFill>
-                            <a:srgbClr val="183B36"/>
-                          </a:solidFill>
-                          <a:latin typeface="Arial"/>
-                          <a:ea typeface="Arial"/>
-                          <a:cs typeface="Arial"/>
-                        </a:rPr>
-                        <a:t>55,29777</a:t>
-                      </a:r>
-                    </a:p>
-                  </a:txBody>
-                  <a:tcPr marL="91440" marR="91440" marT="45720" marB="45720">
-                    <a:solidFill>
-                      <a:srgbClr val="E7EDDF"/>
-                    </a:solidFill>
-                  </a:tcPr>
-                </a:tc>
-              </a:tr>
-              <a:tr h="685800">
-                <a:tc>
-                  <a:txBody>
-                    <a:bodyPr/>
-                    <a:lstStyle/>
-                    <a:p>
-                      <a:r>
-                        <a:rPr sz="2100" b="0">
-                          <a:solidFill>
-                            <a:srgbClr val="183B36"/>
-                          </a:solidFill>
-                          <a:latin typeface="Arial"/>
-                          <a:ea typeface="Arial"/>
-                          <a:cs typeface="Arial"/>
-                        </a:rPr>
-                        <a:t>Показателей ниже 40</a:t>
-                      </a:r>
-                    </a:p>
-                  </a:txBody>
-                  <a:tcPr marL="91440" marR="91440" marT="45720" marB="45720">
-                    <a:solidFill>
-                      <a:srgbClr val="FFFEF9"/>
-                    </a:solidFill>
-                  </a:tcPr>
-                </a:tc>
-                <a:tc>
-                  <a:txBody>
-                    <a:bodyPr/>
-                    <a:lstStyle/>
-                    <a:p>
-                      <a:r>
-                        <a:rPr sz="2100" b="0">
-                          <a:solidFill>
-                            <a:srgbClr val="183B36"/>
-                          </a:solidFill>
-                          <a:latin typeface="Arial"/>
-                          <a:ea typeface="Arial"/>
-                          <a:cs typeface="Arial"/>
-                        </a:rPr>
-                        <a:t>2</a:t>
-                      </a:r>
-                    </a:p>
-                  </a:txBody>
-                  <a:tcPr marL="91440" marR="91440" marT="45720" marB="45720">
-                    <a:solidFill>
-                      <a:srgbClr val="FFFEF9"/>
-                    </a:solidFill>
-                  </a:tcPr>
-                </a:tc>
-                <a:tc>
-                  <a:txBody>
-                    <a:bodyPr/>
-                    <a:lstStyle/>
-                    <a:p>
-                      <a:r>
-                        <a:rPr sz="2100" b="0">
-                          <a:solidFill>
-                            <a:srgbClr val="183B36"/>
-                          </a:solidFill>
-                          <a:latin typeface="Arial"/>
-                          <a:ea typeface="Arial"/>
-                          <a:cs typeface="Arial"/>
-                        </a:rPr>
-                        <a:t>0</a:t>
-                      </a:r>
-                    </a:p>
-                  </a:txBody>
-                  <a:tcPr marL="91440" marR="91440" marT="45720" marB="45720">
-                    <a:solidFill>
-                      <a:srgbClr val="FFFEF9"/>
-                    </a:solidFill>
-                  </a:tcPr>
-                </a:tc>
-                <a:tc>
-                  <a:txBody>
-                    <a:bodyPr/>
-                    <a:lstStyle/>
-                    <a:p>
-                      <a:r>
-                        <a:rPr sz="2100" b="0">
+                        <a:rPr sz="1800" b="0">
                           <a:solidFill>
                             <a:srgbClr val="183B36"/>
                           </a:solidFill>
@@ -4446,10 +4384,10 @@
       </p:graphicFrame>
       <p:sp>
         <p:nvSpPr>
-          <p:cNvPr id="4" name="">
+          <p:cNvPr id="9" name="">
             <a:extLst xmlns:a="http://schemas.openxmlformats.org/drawingml/2006/main">
               <a:ext uri="{FF2B5EF4-FFF2-40B4-BE49-F238E27FC236}">
-                <a16:creationId xmlns:a16="http://schemas.microsoft.com/office/drawing/2014/main" id="{3AE117C0-C863-4195-893A-44144F592193}"/>
+                <a16:creationId xmlns:a16="http://schemas.microsoft.com/office/drawing/2014/main" id="{3A736FAE-C56F-47C9-8B6A-C3B346CA3989}"/>
               </a:ext>
             </a:extLst>
           </p:cNvPr>
@@ -4460,8 +4398,8 @@
         </p:nvSpPr>
         <p:spPr>
           <a:xfrm xmlns:a="http://schemas.openxmlformats.org/drawingml/2006/main">
-            <a:off x="666750" y="5457825"/>
-            <a:ext cx="10810875" cy="581025"/>
+            <a:off x="695325" y="6219825"/>
+            <a:ext cx="10858500" cy="371475"/>
           </a:xfrm>
           <a:prstGeom xmlns:a="http://schemas.openxmlformats.org/drawingml/2006/main" prst="rect">
             <a:avLst/>
@@ -4478,64 +4416,7 @@
           <a:lstStyle xmlns:a="http://schemas.openxmlformats.org/drawingml/2006/main"/>
           <a:p xmlns:a="http://schemas.openxmlformats.org/drawingml/2006/main">
             <a:pPr>
-              <a:defRPr sz="2550" b="1">
-                <a:solidFill>
-                  <a:srgbClr val="194E42"/>
-                </a:solidFill>
-                <a:latin typeface="Arial"/>
-                <a:ea typeface="Arial"/>
-                <a:cs typeface="Arial"/>
-              </a:defRPr>
-            </a:pPr>
-            <a:r>
-              <a:rPr sz="2550" b="1">
-                <a:solidFill>
-                  <a:srgbClr val="194E42"/>
-                </a:solidFill>
-                <a:latin typeface="Arial"/>
-                <a:ea typeface="Arial"/>
-                <a:cs typeface="Arial"/>
-              </a:rPr>
-              <a:t>A выше B на 1,24530 балла</a:t>
-            </a:r>
-          </a:p>
-        </p:txBody>
-      </p:sp>
-      <p:sp>
-        <p:nvSpPr>
-          <p:cNvPr id="5" name="">
-            <a:extLst xmlns:a="http://schemas.openxmlformats.org/drawingml/2006/main">
-              <a:ext uri="{FF2B5EF4-FFF2-40B4-BE49-F238E27FC236}">
-                <a16:creationId xmlns:a16="http://schemas.microsoft.com/office/drawing/2014/main" id="{9EA7B2A2-5E4F-4F56-B9C9-2D964682FA43}"/>
-              </a:ext>
-            </a:extLst>
-          </p:cNvPr>
-          <p:cNvSpPr>
-            <a:spLocks xmlns:a="http://schemas.openxmlformats.org/drawingml/2006/main" noGrp="1"/>
-          </p:cNvSpPr>
-          <p:nvPr/>
-        </p:nvSpPr>
-        <p:spPr>
-          <a:xfrm xmlns:a="http://schemas.openxmlformats.org/drawingml/2006/main">
-            <a:off x="666750" y="6115050"/>
-            <a:ext cx="10810875" cy="371475"/>
-          </a:xfrm>
-          <a:prstGeom xmlns:a="http://schemas.openxmlformats.org/drawingml/2006/main" prst="rect">
-            <a:avLst/>
-          </a:prstGeom>
-          <a:noFill xmlns:a="http://schemas.openxmlformats.org/drawingml/2006/main"/>
-          <a:ln xmlns:a="http://schemas.openxmlformats.org/drawingml/2006/main" w="0">
-            <a:noFill/>
-          </a:ln>
-        </p:spPr>
-        <p:txBody>
-          <a:bodyPr xmlns:a="http://schemas.openxmlformats.org/drawingml/2006/main">
-            <a:noAutofit/>
-          </a:bodyPr>
-          <a:lstStyle xmlns:a="http://schemas.openxmlformats.org/drawingml/2006/main"/>
-          <a:p xmlns:a="http://schemas.openxmlformats.org/drawingml/2006/main">
-            <a:pPr>
-              <a:defRPr sz="1500" b="0">
+              <a:defRPr sz="1575" b="0">
                 <a:solidFill>
                   <a:srgbClr val="62736B"/>
                 </a:solidFill>
@@ -4545,7 +4426,7 @@
               </a:defRPr>
             </a:pPr>
             <a:r>
-              <a:rPr sz="1500" b="0">
+              <a:rPr sz="1575" b="0">
                 <a:solidFill>
                   <a:srgbClr val="62736B"/>
                 </a:solidFill>
@@ -4553,7 +4434,7 @@
                 <a:ea typeface="Arial"/>
                 <a:cs typeface="Arial"/>
               </a:rPr>
-              <a:t>Остальные меры одинаковы: M8 и M10 в Нуре, M12 по городу, M5 в Сарыарке.</a:t>
+              <a:t>До решений: Score 52,55768 и 2 критических показателя. Остальные меры одинаковы.</a:t>
             </a:r>
           </a:p>
         </p:txBody>
@@ -4561,7 +4442,7 @@
     </p:spTree>
     <p:extLst>
       <p:ext uri="{BB962C8B-B14F-4D97-AF65-F5344CB8AC3E}">
-        <p14:creationId xmlns:p14="http://schemas.microsoft.com/office/powerpoint/2010/main" val="578592091"/>
+        <p14:creationId xmlns:p14="http://schemas.microsoft.com/office/powerpoint/2010/main" val="1843382206"/>
       </p:ext>
     </p:extLst>
   </p:cSld>
@@ -4592,7 +4473,7 @@
           <p:cNvPr id="10" name="">
             <a:extLst xmlns:a="http://schemas.openxmlformats.org/drawingml/2006/main">
               <a:ext uri="{FF2B5EF4-FFF2-40B4-BE49-F238E27FC236}">
-                <a16:creationId xmlns:a16="http://schemas.microsoft.com/office/drawing/2014/main" id="{B5F0A6D0-A517-4191-B3D9-77D2ADD514FF}"/>
+                <a16:creationId xmlns:a16="http://schemas.microsoft.com/office/drawing/2014/main" id="{B2296837-6CEF-4AC0-85D4-F66B923099FF}"/>
               </a:ext>
             </a:extLst>
           </p:cNvPr>
@@ -4639,7 +4520,7 @@
                 <a:ea typeface="Georgia"/>
                 <a:cs typeface="Georgia"/>
               </a:rPr>
-              <a:t>Работающий прототип</a:t>
+              <a:t>Прототип готов к демонстрации</a:t>
             </a:r>
           </a:p>
         </p:txBody>
@@ -4649,7 +4530,7 @@
           <p:cNvPr id="2" name="">
             <a:extLst xmlns:a="http://schemas.openxmlformats.org/drawingml/2006/main">
               <a:ext uri="{FF2B5EF4-FFF2-40B4-BE49-F238E27FC236}">
-                <a16:creationId xmlns:a16="http://schemas.microsoft.com/office/drawing/2014/main" id="{7131FE12-97FF-4D59-84DF-1CCF44297EC0}"/>
+                <a16:creationId xmlns:a16="http://schemas.microsoft.com/office/drawing/2014/main" id="{942A3AF5-9A70-49D9-8D50-FFFA47BFCA90}"/>
               </a:ext>
             </a:extLst>
           </p:cNvPr>
@@ -4660,8 +4541,8 @@
         </p:nvSpPr>
         <p:spPr>
           <a:xfrm xmlns:a="http://schemas.openxmlformats.org/drawingml/2006/main">
-            <a:off x="647700" y="1924050"/>
-            <a:ext cx="3143250" cy="1428750"/>
+            <a:off x="619125" y="1952625"/>
+            <a:ext cx="4191000" cy="1933575"/>
           </a:xfrm>
           <a:prstGeom xmlns:a="http://schemas.openxmlformats.org/drawingml/2006/main" prst="rect">
             <a:avLst/>
@@ -4678,7 +4559,7 @@
           <a:lstStyle xmlns:a="http://schemas.openxmlformats.org/drawingml/2006/main"/>
           <a:p xmlns:a="http://schemas.openxmlformats.org/drawingml/2006/main">
             <a:pPr>
-              <a:defRPr sz="9750" b="1">
+              <a:defRPr sz="12000" b="1">
                 <a:solidFill>
                   <a:srgbClr val="194E42"/>
                 </a:solidFill>
@@ -4688,7 +4569,7 @@
               </a:defRPr>
             </a:pPr>
             <a:r>
-              <a:rPr sz="9750" b="1">
+              <a:rPr sz="12000" b="1">
                 <a:solidFill>
                   <a:srgbClr val="194E42"/>
                 </a:solidFill>
@@ -4706,7 +4587,7 @@
           <p:cNvPr id="3" name="">
             <a:extLst xmlns:a="http://schemas.openxmlformats.org/drawingml/2006/main">
               <a:ext uri="{FF2B5EF4-FFF2-40B4-BE49-F238E27FC236}">
-                <a16:creationId xmlns:a16="http://schemas.microsoft.com/office/drawing/2014/main" id="{D81FD010-95F7-4EA5-9941-F08E555F9D02}"/>
+                <a16:creationId xmlns:a16="http://schemas.microsoft.com/office/drawing/2014/main" id="{0043475F-540B-4A65-9FA1-107EC28C4824}"/>
               </a:ext>
             </a:extLst>
           </p:cNvPr>
@@ -4717,8 +4598,8 @@
         </p:nvSpPr>
         <p:spPr>
           <a:xfrm xmlns:a="http://schemas.openxmlformats.org/drawingml/2006/main">
-            <a:off x="704850" y="3657600"/>
-            <a:ext cx="3429000" cy="1047750"/>
+            <a:off x="695325" y="4048125"/>
+            <a:ext cx="4381500" cy="552450"/>
           </a:xfrm>
           <a:prstGeom xmlns:a="http://schemas.openxmlformats.org/drawingml/2006/main" prst="rect">
             <a:avLst/>
@@ -4735,48 +4616,25 @@
           <a:lstStyle xmlns:a="http://schemas.openxmlformats.org/drawingml/2006/main"/>
           <a:p xmlns:a="http://schemas.openxmlformats.org/drawingml/2006/main">
             <a:pPr>
-              <a:defRPr sz="2175" b="0">
-                <a:solidFill>
-                  <a:srgbClr val="62736B"/>
-                </a:solidFill>
-                <a:latin typeface="Arial"/>
-                <a:ea typeface="Arial"/>
-                <a:cs typeface="Arial"/>
-              </a:defRPr>
-            </a:pPr>
-            <a:r>
-              <a:rPr sz="2175" b="0">
-                <a:solidFill>
-                  <a:srgbClr val="62736B"/>
-                </a:solidFill>
-                <a:latin typeface="Arial"/>
-                <a:ea typeface="Arial"/>
-                <a:cs typeface="Arial"/>
-              </a:rPr>
-              <a:t>автоматических тестов</a:t>
-            </a:r>
-          </a:p>
-          <a:p xmlns:a="http://schemas.openxmlformats.org/drawingml/2006/main">
-            <a:pPr>
-              <a:defRPr sz="2175" b="0">
-                <a:solidFill>
-                  <a:srgbClr val="62736B"/>
-                </a:solidFill>
-                <a:latin typeface="Arial"/>
-                <a:ea typeface="Arial"/>
-                <a:cs typeface="Arial"/>
-              </a:defRPr>
-            </a:pPr>
-            <a:r>
-              <a:rPr sz="2175" b="0">
-                <a:solidFill>
-                  <a:srgbClr val="62736B"/>
-                </a:solidFill>
-                <a:latin typeface="Arial"/>
-                <a:ea typeface="Arial"/>
-                <a:cs typeface="Arial"/>
-              </a:rPr>
-              <a:t>проходят</a:t>
+              <a:defRPr sz="2700" b="0">
+                <a:solidFill>
+                  <a:srgbClr val="183B36"/>
+                </a:solidFill>
+                <a:latin typeface="Arial"/>
+                <a:ea typeface="Arial"/>
+                <a:cs typeface="Arial"/>
+              </a:defRPr>
+            </a:pPr>
+            <a:r>
+              <a:rPr sz="2700" b="0">
+                <a:solidFill>
+                  <a:srgbClr val="183B36"/>
+                </a:solidFill>
+                <a:latin typeface="Arial"/>
+                <a:ea typeface="Arial"/>
+                <a:cs typeface="Arial"/>
+              </a:rPr>
+              <a:t>тестов проходит</a:t>
             </a:r>
           </a:p>
         </p:txBody>
@@ -4786,7 +4644,7 @@
           <p:cNvPr id="4" name="">
             <a:extLst xmlns:a="http://schemas.openxmlformats.org/drawingml/2006/main">
               <a:ext uri="{FF2B5EF4-FFF2-40B4-BE49-F238E27FC236}">
-                <a16:creationId xmlns:a16="http://schemas.microsoft.com/office/drawing/2014/main" id="{7736E533-1144-4C4B-BCC0-0CD4E6DF4D0C}"/>
+                <a16:creationId xmlns:a16="http://schemas.microsoft.com/office/drawing/2014/main" id="{FD5D7B92-C3AB-48E5-B787-1654F6AFA289}"/>
               </a:ext>
             </a:extLst>
           </p:cNvPr>
@@ -4797,8 +4655,8 @@
         </p:nvSpPr>
         <p:spPr>
           <a:xfrm xmlns:a="http://schemas.openxmlformats.org/drawingml/2006/main">
-            <a:off x="5381625" y="1924050"/>
-            <a:ext cx="6191250" cy="457200"/>
+            <a:off x="5810250" y="2000250"/>
+            <a:ext cx="5715000" cy="504825"/>
           </a:xfrm>
           <a:prstGeom xmlns:a="http://schemas.openxmlformats.org/drawingml/2006/main" prst="rect">
             <a:avLst/>
@@ -4815,7 +4673,7 @@
           <a:lstStyle xmlns:a="http://schemas.openxmlformats.org/drawingml/2006/main"/>
           <a:p xmlns:a="http://schemas.openxmlformats.org/drawingml/2006/main">
             <a:pPr>
-              <a:defRPr sz="2325" b="1">
+              <a:defRPr sz="2700" b="1">
                 <a:solidFill>
                   <a:srgbClr val="183B36"/>
                 </a:solidFill>
@@ -4825,7 +4683,7 @@
               </a:defRPr>
             </a:pPr>
             <a:r>
-              <a:rPr sz="2325" b="1">
+              <a:rPr sz="2700" b="1">
                 <a:solidFill>
                   <a:srgbClr val="183B36"/>
                 </a:solidFill>
@@ -4833,7 +4691,7 @@
                 <a:ea typeface="Arial"/>
                 <a:cs typeface="Arial"/>
               </a:rPr>
-              <a:t>Локальная числовая модель</a:t>
+              <a:t>Python 3.10+</a:t>
             </a:r>
           </a:p>
         </p:txBody>
@@ -4843,7 +4701,7 @@
           <p:cNvPr id="5" name="">
             <a:extLst xmlns:a="http://schemas.openxmlformats.org/drawingml/2006/main">
               <a:ext uri="{FF2B5EF4-FFF2-40B4-BE49-F238E27FC236}">
-                <a16:creationId xmlns:a16="http://schemas.microsoft.com/office/drawing/2014/main" id="{D46C9211-F107-4AFE-A544-73355CF6F80D}"/>
+                <a16:creationId xmlns:a16="http://schemas.microsoft.com/office/drawing/2014/main" id="{67B31646-E914-4109-961C-5D8452075626}"/>
               </a:ext>
             </a:extLst>
           </p:cNvPr>
@@ -4854,8 +4712,8 @@
         </p:nvSpPr>
         <p:spPr>
           <a:xfrm xmlns:a="http://schemas.openxmlformats.org/drawingml/2006/main">
-            <a:off x="5381625" y="2466975"/>
-            <a:ext cx="6191250" cy="609600"/>
+            <a:off x="5810250" y="2619375"/>
+            <a:ext cx="5715000" cy="914400"/>
           </a:xfrm>
           <a:prstGeom xmlns:a="http://schemas.openxmlformats.org/drawingml/2006/main" prst="rect">
             <a:avLst/>
@@ -4872,7 +4730,7 @@
           <a:lstStyle xmlns:a="http://schemas.openxmlformats.org/drawingml/2006/main"/>
           <a:p xmlns:a="http://schemas.openxmlformats.org/drawingml/2006/main">
             <a:pPr>
-              <a:defRPr sz="1950" b="0">
+              <a:defRPr sz="2100" b="0">
                 <a:solidFill>
                   <a:srgbClr val="62736B"/>
                 </a:solidFill>
@@ -4882,7 +4740,7 @@
               </a:defRPr>
             </a:pPr>
             <a:r>
-              <a:rPr sz="1950" b="0">
+              <a:rPr sz="2100" b="0">
                 <a:solidFill>
                   <a:srgbClr val="62736B"/>
                 </a:solidFill>
@@ -4890,7 +4748,30 @@
                 <a:ea typeface="Arial"/>
                 <a:cs typeface="Arial"/>
               </a:rPr>
-              <a:t>Python 3.10+, стандартная библиотека</a:t>
+              <a:t>Локальный расчёт</a:t>
+            </a:r>
+          </a:p>
+          <a:p xmlns:a="http://schemas.openxmlformats.org/drawingml/2006/main">
+            <a:pPr>
+              <a:defRPr sz="2100" b="0">
+                <a:solidFill>
+                  <a:srgbClr val="62736B"/>
+                </a:solidFill>
+                <a:latin typeface="Arial"/>
+                <a:ea typeface="Arial"/>
+                <a:cs typeface="Arial"/>
+              </a:defRPr>
+            </a:pPr>
+            <a:r>
+              <a:rPr sz="2100" b="0">
+                <a:solidFill>
+                  <a:srgbClr val="62736B"/>
+                </a:solidFill>
+                <a:latin typeface="Arial"/>
+                <a:ea typeface="Arial"/>
+                <a:cs typeface="Arial"/>
+              </a:rPr>
+              <a:t>Стандартная библиотека</a:t>
             </a:r>
           </a:p>
         </p:txBody>
@@ -4900,7 +4781,7 @@
           <p:cNvPr id="6" name="">
             <a:extLst xmlns:a="http://schemas.openxmlformats.org/drawingml/2006/main">
               <a:ext uri="{FF2B5EF4-FFF2-40B4-BE49-F238E27FC236}">
-                <a16:creationId xmlns:a16="http://schemas.microsoft.com/office/drawing/2014/main" id="{16FFC1F7-C829-43E9-A9DD-45440E67C3C3}"/>
+                <a16:creationId xmlns:a16="http://schemas.microsoft.com/office/drawing/2014/main" id="{487CD315-CDE8-42D5-A2C7-CB00E9660BEA}"/>
               </a:ext>
             </a:extLst>
           </p:cNvPr>
@@ -4911,8 +4792,8 @@
         </p:nvSpPr>
         <p:spPr>
           <a:xfrm xmlns:a="http://schemas.openxmlformats.org/drawingml/2006/main">
-            <a:off x="5381625" y="3486150"/>
-            <a:ext cx="6191250" cy="466725"/>
+            <a:off x="5810250" y="3876675"/>
+            <a:ext cx="5715000" cy="504825"/>
           </a:xfrm>
           <a:prstGeom xmlns:a="http://schemas.openxmlformats.org/drawingml/2006/main" prst="rect">
             <a:avLst/>
@@ -4929,7 +4810,7 @@
           <a:lstStyle xmlns:a="http://schemas.openxmlformats.org/drawingml/2006/main"/>
           <a:p xmlns:a="http://schemas.openxmlformats.org/drawingml/2006/main">
             <a:pPr>
-              <a:defRPr sz="2325" b="1">
+              <a:defRPr sz="2700" b="1">
                 <a:solidFill>
                   <a:srgbClr val="183B36"/>
                 </a:solidFill>
@@ -4939,7 +4820,7 @@
               </a:defRPr>
             </a:pPr>
             <a:r>
-              <a:rPr sz="2325" b="1">
+              <a:rPr sz="2700" b="1">
                 <a:solidFill>
                   <a:srgbClr val="183B36"/>
                 </a:solidFill>
@@ -4947,7 +4828,7 @@
                 <a:ea typeface="Arial"/>
                 <a:cs typeface="Arial"/>
               </a:rPr>
-              <a:t>Настоящий AI-запрос проверен</a:t>
+              <a:t>Настоящий OpenAI API</a:t>
             </a:r>
           </a:p>
         </p:txBody>
@@ -4957,7 +4838,7 @@
           <p:cNvPr id="7" name="">
             <a:extLst xmlns:a="http://schemas.openxmlformats.org/drawingml/2006/main">
               <a:ext uri="{FF2B5EF4-FFF2-40B4-BE49-F238E27FC236}">
-                <a16:creationId xmlns:a16="http://schemas.microsoft.com/office/drawing/2014/main" id="{DB159167-FE57-4EDE-BF49-572161126C0D}"/>
+                <a16:creationId xmlns:a16="http://schemas.microsoft.com/office/drawing/2014/main" id="{842A0792-E332-4303-9B6D-2CFE6E0F7A2A}"/>
               </a:ext>
             </a:extLst>
           </p:cNvPr>
@@ -4968,8 +4849,8 @@
         </p:nvSpPr>
         <p:spPr>
           <a:xfrm xmlns:a="http://schemas.openxmlformats.org/drawingml/2006/main">
-            <a:off x="5381625" y="4029075"/>
-            <a:ext cx="6191250" cy="581025"/>
+            <a:off x="5810250" y="4495800"/>
+            <a:ext cx="5715000" cy="561975"/>
           </a:xfrm>
           <a:prstGeom xmlns:a="http://schemas.openxmlformats.org/drawingml/2006/main" prst="rect">
             <a:avLst/>
@@ -4986,7 +4867,7 @@
           <a:lstStyle xmlns:a="http://schemas.openxmlformats.org/drawingml/2006/main"/>
           <a:p xmlns:a="http://schemas.openxmlformats.org/drawingml/2006/main">
             <a:pPr>
-              <a:defRPr sz="1950" b="0">
+              <a:defRPr sz="2100" b="0">
                 <a:solidFill>
                   <a:srgbClr val="62736B"/>
                 </a:solidFill>
@@ -4996,7 +4877,7 @@
               </a:defRPr>
             </a:pPr>
             <a:r>
-              <a:rPr sz="1950" b="0">
+              <a:rPr sz="2100" b="0">
                 <a:solidFill>
                   <a:srgbClr val="62736B"/>
                 </a:solidFill>
@@ -5004,7 +4885,7 @@
                 <a:ea typeface="Arial"/>
                 <a:cs typeface="Arial"/>
               </a:rPr>
-              <a:t>OpenAI API, проверка 23 сентября 2026</a:t>
+              <a:t>Запрос проверен 23 сентября 2026</a:t>
             </a:r>
           </a:p>
         </p:txBody>
@@ -5014,7 +4895,7 @@
           <p:cNvPr id="8" name="">
             <a:extLst xmlns:a="http://schemas.openxmlformats.org/drawingml/2006/main">
               <a:ext uri="{FF2B5EF4-FFF2-40B4-BE49-F238E27FC236}">
-                <a16:creationId xmlns:a16="http://schemas.microsoft.com/office/drawing/2014/main" id="{6EF57EF6-0514-4BEA-8038-C84FA5B54AFF}"/>
+                <a16:creationId xmlns:a16="http://schemas.microsoft.com/office/drawing/2014/main" id="{0CC2C75F-FF0D-4821-8BF7-2918DAAF7715}"/>
               </a:ext>
             </a:extLst>
           </p:cNvPr>
@@ -5025,8 +4906,8 @@
         </p:nvSpPr>
         <p:spPr>
           <a:xfrm xmlns:a="http://schemas.openxmlformats.org/drawingml/2006/main">
-            <a:off x="685800" y="5257800"/>
-            <a:ext cx="10858500" cy="571500"/>
+            <a:off x="695325" y="5629275"/>
+            <a:ext cx="10858500" cy="504825"/>
           </a:xfrm>
           <a:prstGeom xmlns:a="http://schemas.openxmlformats.org/drawingml/2006/main" prst="rect">
             <a:avLst/>
@@ -5043,25 +4924,25 @@
           <a:lstStyle xmlns:a="http://schemas.openxmlformats.org/drawingml/2006/main"/>
           <a:p xmlns:a="http://schemas.openxmlformats.org/drawingml/2006/main">
             <a:pPr>
-              <a:defRPr sz="2250" b="0">
-                <a:solidFill>
-                  <a:srgbClr val="183B36"/>
-                </a:solidFill>
-                <a:latin typeface="Arial"/>
-                <a:ea typeface="Arial"/>
-                <a:cs typeface="Arial"/>
-              </a:defRPr>
-            </a:pPr>
-            <a:r>
-              <a:rPr sz="2250" b="0">
-                <a:solidFill>
-                  <a:srgbClr val="183B36"/>
-                </a:solidFill>
-                <a:latin typeface="Arial"/>
-                <a:ea typeface="Arial"/>
-                <a:cs typeface="Arial"/>
-              </a:rPr>
-              <a:t>Сравнение A/B, AI-разбор и скачивание отчёта</a:t>
+              <a:defRPr sz="2400" b="1">
+                <a:solidFill>
+                  <a:srgbClr val="194E42"/>
+                </a:solidFill>
+                <a:latin typeface="Arial"/>
+                <a:ea typeface="Arial"/>
+                <a:cs typeface="Arial"/>
+              </a:defRPr>
+            </a:pPr>
+            <a:r>
+              <a:rPr sz="2400" b="1">
+                <a:solidFill>
+                  <a:srgbClr val="194E42"/>
+                </a:solidFill>
+                <a:latin typeface="Arial"/>
+                <a:ea typeface="Arial"/>
+                <a:cs typeface="Arial"/>
+              </a:rPr>
+              <a:t>Сравнение A/B и скачивание отчёта</a:t>
             </a:r>
           </a:p>
         </p:txBody>
@@ -5071,7 +4952,7 @@
           <p:cNvPr id="9" name="">
             <a:extLst xmlns:a="http://schemas.openxmlformats.org/drawingml/2006/main">
               <a:ext uri="{FF2B5EF4-FFF2-40B4-BE49-F238E27FC236}">
-                <a16:creationId xmlns:a16="http://schemas.microsoft.com/office/drawing/2014/main" id="{A5FBB7D9-DE46-4124-AFE9-83272FB8C856}"/>
+                <a16:creationId xmlns:a16="http://schemas.microsoft.com/office/drawing/2014/main" id="{EBDD16F3-96A6-4555-9517-8E56F487157F}"/>
               </a:ext>
             </a:extLst>
           </p:cNvPr>
@@ -5082,8 +4963,8 @@
         </p:nvSpPr>
         <p:spPr>
           <a:xfrm xmlns:a="http://schemas.openxmlformats.org/drawingml/2006/main">
-            <a:off x="685800" y="6057900"/>
-            <a:ext cx="10858500" cy="409575"/>
+            <a:off x="695325" y="6305550"/>
+            <a:ext cx="10858500" cy="295275"/>
           </a:xfrm>
           <a:prstGeom xmlns:a="http://schemas.openxmlformats.org/drawingml/2006/main" prst="rect">
             <a:avLst/>
@@ -5100,7 +4981,7 @@
           <a:lstStyle xmlns:a="http://schemas.openxmlformats.org/drawingml/2006/main"/>
           <a:p xmlns:a="http://schemas.openxmlformats.org/drawingml/2006/main">
             <a:pPr>
-              <a:defRPr sz="1575" b="0">
+              <a:defRPr sz="1425" b="0">
                 <a:solidFill>
                   <a:srgbClr val="62736B"/>
                 </a:solidFill>
@@ -5110,7 +4991,7 @@
               </a:defRPr>
             </a:pPr>
             <a:r>
-              <a:rPr sz="1575" b="0">
+              <a:rPr sz="1425" b="0">
                 <a:solidFill>
                   <a:srgbClr val="62736B"/>
                 </a:solidFill>
@@ -5118,7 +4999,7 @@
                 <a:ea typeface="Arial"/>
                 <a:cs typeface="Arial"/>
               </a:rPr>
-              <a:t>Код, интерфейс и материалы разработаны с существенной помощью OpenAI Codex.</a:t>
+              <a:t>Код, интерфейс и материалы созданы с существенной помощью OpenAI Codex.</a:t>
             </a:r>
           </a:p>
         </p:txBody>
@@ -5126,7 +5007,7 @@
     </p:spTree>
     <p:extLst>
       <p:ext uri="{BB962C8B-B14F-4D97-AF65-F5344CB8AC3E}">
-        <p14:creationId xmlns:p14="http://schemas.microsoft.com/office/powerpoint/2010/main" val="452151383"/>
+        <p14:creationId xmlns:p14="http://schemas.microsoft.com/office/powerpoint/2010/main" val="1530555297"/>
       </p:ext>
     </p:extLst>
   </p:cSld>
@@ -5139,7 +5020,7 @@
     <p:bg>
       <p:bgPr>
         <a:solidFill xmlns:a="http://schemas.openxmlformats.org/drawingml/2006/main">
-          <a:srgbClr val="F5F2E8"/>
+          <a:srgbClr val="194E42"/>
         </a:solidFill>
       </p:bgPr>
     </p:bg>
@@ -5154,10 +5035,10 @@
       </p:grpSpPr>
       <p:sp>
         <p:nvSpPr>
-          <p:cNvPr id="6" name="">
+          <p:cNvPr id="5" name="">
             <a:extLst xmlns:a="http://schemas.openxmlformats.org/drawingml/2006/main">
               <a:ext uri="{FF2B5EF4-FFF2-40B4-BE49-F238E27FC236}">
-                <a16:creationId xmlns:a16="http://schemas.microsoft.com/office/drawing/2014/main" id="{D204B0B2-2D1D-4F17-9E17-359985898515}"/>
+                <a16:creationId xmlns:a16="http://schemas.microsoft.com/office/drawing/2014/main" id="{3717DD4C-88A1-42E5-92AB-A1F276737699}"/>
               </a:ext>
             </a:extLst>
           </p:cNvPr>
@@ -5168,8 +5049,8 @@
         </p:nvSpPr>
         <p:spPr>
           <a:xfrm xmlns:a="http://schemas.openxmlformats.org/drawingml/2006/main">
-            <a:off x="628650" y="495300"/>
-            <a:ext cx="10934700" cy="876300"/>
+            <a:off x="628650" y="952500"/>
+            <a:ext cx="10934700" cy="1809750"/>
           </a:xfrm>
           <a:prstGeom xmlns:a="http://schemas.openxmlformats.org/drawingml/2006/main" prst="rect">
             <a:avLst/>
@@ -5186,9 +5067,9 @@
           <a:lstStyle xmlns:a="http://schemas.openxmlformats.org/drawingml/2006/main"/>
           <a:p xmlns:a="http://schemas.openxmlformats.org/drawingml/2006/main">
             <a:pPr>
-              <a:defRPr sz="3375" b="0">
-                <a:solidFill>
-                  <a:srgbClr val="183B36"/>
+              <a:defRPr sz="4800" b="0">
+                <a:solidFill>
+                  <a:srgbClr val="F5F2E8"/>
                 </a:solidFill>
                 <a:latin typeface="Georgia"/>
                 <a:ea typeface="Georgia"/>
@@ -5196,15 +5077,38 @@
               </a:defRPr>
             </a:pPr>
             <a:r>
-              <a:rPr sz="3375" b="0">
-                <a:solidFill>
-                  <a:srgbClr val="183B36"/>
+              <a:rPr sz="4800" b="0">
+                <a:solidFill>
+                  <a:srgbClr val="F5F2E8"/>
                 </a:solidFill>
                 <a:latin typeface="Georgia"/>
                 <a:ea typeface="Georgia"/>
                 <a:cs typeface="Georgia"/>
               </a:rPr>
-              <a:t>Демонстрация и пределы модели</a:t>
+              <a:t>Сравните планы</a:t>
+            </a:r>
+          </a:p>
+          <a:p xmlns:a="http://schemas.openxmlformats.org/drawingml/2006/main">
+            <a:pPr>
+              <a:defRPr sz="4800" b="0">
+                <a:solidFill>
+                  <a:srgbClr val="F5F2E8"/>
+                </a:solidFill>
+                <a:latin typeface="Georgia"/>
+                <a:ea typeface="Georgia"/>
+                <a:cs typeface="Georgia"/>
+              </a:defRPr>
+            </a:pPr>
+            <a:r>
+              <a:rPr sz="4800" b="0">
+                <a:solidFill>
+                  <a:srgbClr val="F5F2E8"/>
+                </a:solidFill>
+                <a:latin typeface="Georgia"/>
+                <a:ea typeface="Georgia"/>
+                <a:cs typeface="Georgia"/>
+              </a:rPr>
+              <a:t>до принятия решения</a:t>
             </a:r>
           </a:p>
         </p:txBody>
@@ -5214,7 +5118,7 @@
           <p:cNvPr id="2" name="">
             <a:extLst xmlns:a="http://schemas.openxmlformats.org/drawingml/2006/main">
               <a:ext uri="{FF2B5EF4-FFF2-40B4-BE49-F238E27FC236}">
-                <a16:creationId xmlns:a16="http://schemas.microsoft.com/office/drawing/2014/main" id="{F80AD75A-2FD6-42B6-AFF5-4925DB1EBC29}"/>
+                <a16:creationId xmlns:a16="http://schemas.microsoft.com/office/drawing/2014/main" id="{74BDD3C2-8139-4313-8EE6-B49C1079DBC5}"/>
               </a:ext>
             </a:extLst>
           </p:cNvPr>
@@ -5225,8 +5129,8 @@
         </p:nvSpPr>
         <p:spPr>
           <a:xfrm xmlns:a="http://schemas.openxmlformats.org/drawingml/2006/main">
-            <a:off x="685800" y="1724025"/>
-            <a:ext cx="10858500" cy="666750"/>
+            <a:off x="695325" y="3381375"/>
+            <a:ext cx="10668000" cy="1114425"/>
           </a:xfrm>
           <a:prstGeom xmlns:a="http://schemas.openxmlformats.org/drawingml/2006/main" prst="rect">
             <a:avLst/>
@@ -5243,25 +5147,48 @@
           <a:lstStyle xmlns:a="http://schemas.openxmlformats.org/drawingml/2006/main"/>
           <a:p xmlns:a="http://schemas.openxmlformats.org/drawingml/2006/main">
             <a:pPr>
-              <a:defRPr sz="2550" b="1">
-                <a:solidFill>
-                  <a:srgbClr val="194E42"/>
-                </a:solidFill>
-                <a:latin typeface="Arial"/>
-                <a:ea typeface="Arial"/>
-                <a:cs typeface="Arial"/>
-              </a:defRPr>
-            </a:pPr>
-            <a:r>
-              <a:rPr sz="2550" b="1">
-                <a:solidFill>
-                  <a:srgbClr val="194E42"/>
-                </a:solidFill>
-                <a:latin typeface="Arial"/>
-                <a:ea typeface="Arial"/>
-                <a:cs typeface="Arial"/>
-              </a:rPr>
-              <a:t>Демо: пример организаторов и сравнение A/B</a:t>
+              <a:defRPr sz="2850" b="0">
+                <a:solidFill>
+                  <a:srgbClr val="F5F2E8"/>
+                </a:solidFill>
+                <a:latin typeface="Arial"/>
+                <a:ea typeface="Arial"/>
+                <a:cs typeface="Arial"/>
+              </a:defRPr>
+            </a:pPr>
+            <a:r>
+              <a:rPr sz="2850" b="0">
+                <a:solidFill>
+                  <a:srgbClr val="F5F2E8"/>
+                </a:solidFill>
+                <a:latin typeface="Arial"/>
+                <a:ea typeface="Arial"/>
+                <a:cs typeface="Arial"/>
+              </a:rPr>
+              <a:t>Одна мера. Другой район.</a:t>
+            </a:r>
+          </a:p>
+          <a:p xmlns:a="http://schemas.openxmlformats.org/drawingml/2006/main">
+            <a:pPr>
+              <a:defRPr sz="2850" b="0">
+                <a:solidFill>
+                  <a:srgbClr val="F5F2E8"/>
+                </a:solidFill>
+                <a:latin typeface="Arial"/>
+                <a:ea typeface="Arial"/>
+                <a:cs typeface="Arial"/>
+              </a:defRPr>
+            </a:pPr>
+            <a:r>
+              <a:rPr sz="2850" b="0">
+                <a:solidFill>
+                  <a:srgbClr val="F5F2E8"/>
+                </a:solidFill>
+                <a:latin typeface="Arial"/>
+                <a:ea typeface="Arial"/>
+                <a:cs typeface="Arial"/>
+              </a:rPr>
+              <a:t>Измеримая разница в результате.</a:t>
             </a:r>
           </a:p>
         </p:txBody>
@@ -5271,7 +5198,7 @@
           <p:cNvPr id="3" name="">
             <a:extLst xmlns:a="http://schemas.openxmlformats.org/drawingml/2006/main">
               <a:ext uri="{FF2B5EF4-FFF2-40B4-BE49-F238E27FC236}">
-                <a16:creationId xmlns:a16="http://schemas.microsoft.com/office/drawing/2014/main" id="{17B254C1-2BCC-4C97-BC3E-AF1C50D3CDB1}"/>
+                <a16:creationId xmlns:a16="http://schemas.microsoft.com/office/drawing/2014/main" id="{DC4F4D63-99BA-49C7-AD4E-07F76B962546}"/>
               </a:ext>
             </a:extLst>
           </p:cNvPr>
@@ -5282,8 +5209,8 @@
         </p:nvSpPr>
         <p:spPr>
           <a:xfrm xmlns:a="http://schemas.openxmlformats.org/drawingml/2006/main">
-            <a:off x="685800" y="2667000"/>
-            <a:ext cx="10477500" cy="1143000"/>
+            <a:off x="695325" y="5095875"/>
+            <a:ext cx="10763250" cy="428625"/>
           </a:xfrm>
           <a:prstGeom xmlns:a="http://schemas.openxmlformats.org/drawingml/2006/main" prst="rect">
             <a:avLst/>
@@ -5300,48 +5227,25 @@
           <a:lstStyle xmlns:a="http://schemas.openxmlformats.org/drawingml/2006/main"/>
           <a:p xmlns:a="http://schemas.openxmlformats.org/drawingml/2006/main">
             <a:pPr>
-              <a:defRPr sz="2550" b="0">
-                <a:solidFill>
-                  <a:srgbClr val="183B36"/>
-                </a:solidFill>
-                <a:latin typeface="Arial"/>
-                <a:ea typeface="Arial"/>
-                <a:cs typeface="Arial"/>
-              </a:defRPr>
-            </a:pPr>
-            <a:r>
-              <a:rPr sz="2550" b="0">
-                <a:solidFill>
-                  <a:srgbClr val="183B36"/>
-                </a:solidFill>
-                <a:latin typeface="Arial"/>
-                <a:ea typeface="Arial"/>
-                <a:cs typeface="Arial"/>
-              </a:rPr>
-              <a:t>Смена района для одной меры показывает,</a:t>
-            </a:r>
-          </a:p>
-          <a:p xmlns:a="http://schemas.openxmlformats.org/drawingml/2006/main">
-            <a:pPr>
-              <a:defRPr sz="2550" b="0">
-                <a:solidFill>
-                  <a:srgbClr val="183B36"/>
-                </a:solidFill>
-                <a:latin typeface="Arial"/>
-                <a:ea typeface="Arial"/>
-                <a:cs typeface="Arial"/>
-              </a:defRPr>
-            </a:pPr>
-            <a:r>
-              <a:rPr sz="2550" b="0">
-                <a:solidFill>
-                  <a:srgbClr val="183B36"/>
-                </a:solidFill>
-                <a:latin typeface="Arial"/>
-                <a:ea typeface="Arial"/>
-                <a:cs typeface="Arial"/>
-              </a:rPr>
-              <a:t>как выбор влияет на город и слабейший район.</a:t>
+              <a:defRPr sz="1800" b="1">
+                <a:solidFill>
+                  <a:srgbClr val="E8C77C"/>
+                </a:solidFill>
+                <a:latin typeface="Arial"/>
+                <a:ea typeface="Arial"/>
+                <a:cs typeface="Arial"/>
+              </a:defRPr>
+            </a:pPr>
+            <a:r>
+              <a:rPr sz="1800" b="1">
+                <a:solidFill>
+                  <a:srgbClr val="E8C77C"/>
+                </a:solidFill>
+                <a:latin typeface="Arial"/>
+                <a:ea typeface="Arial"/>
+                <a:cs typeface="Arial"/>
+              </a:rPr>
+              <a:t>ДЕМО: ПРИМЕР ОРГАНИЗАТОРОВ И A/B</a:t>
             </a:r>
           </a:p>
         </p:txBody>
@@ -5351,7 +5255,7 @@
           <p:cNvPr id="4" name="">
             <a:extLst xmlns:a="http://schemas.openxmlformats.org/drawingml/2006/main">
               <a:ext uri="{FF2B5EF4-FFF2-40B4-BE49-F238E27FC236}">
-                <a16:creationId xmlns:a16="http://schemas.microsoft.com/office/drawing/2014/main" id="{C4850DDB-EE07-4963-9952-850C3EF2C224}"/>
+                <a16:creationId xmlns:a16="http://schemas.microsoft.com/office/drawing/2014/main" id="{D2E98E48-14B8-4DB7-8CAF-30CFF40D4937}"/>
               </a:ext>
             </a:extLst>
           </p:cNvPr>
@@ -5362,8 +5266,8 @@
         </p:nvSpPr>
         <p:spPr>
           <a:xfrm xmlns:a="http://schemas.openxmlformats.org/drawingml/2006/main">
-            <a:off x="685800" y="4381500"/>
-            <a:ext cx="10001250" cy="466725"/>
+            <a:off x="695325" y="5981700"/>
+            <a:ext cx="10763250" cy="609600"/>
           </a:xfrm>
           <a:prstGeom xmlns:a="http://schemas.openxmlformats.org/drawingml/2006/main" prst="rect">
             <a:avLst/>
@@ -5380,76 +5284,19 @@
           <a:lstStyle xmlns:a="http://schemas.openxmlformats.org/drawingml/2006/main"/>
           <a:p xmlns:a="http://schemas.openxmlformats.org/drawingml/2006/main">
             <a:pPr>
-              <a:defRPr sz="2250" b="1">
-                <a:solidFill>
-                  <a:srgbClr val="183B36"/>
-                </a:solidFill>
-                <a:latin typeface="Arial"/>
-                <a:ea typeface="Arial"/>
-                <a:cs typeface="Arial"/>
-              </a:defRPr>
-            </a:pPr>
-            <a:r>
-              <a:rPr sz="2250" b="1">
-                <a:solidFill>
-                  <a:srgbClr val="183B36"/>
-                </a:solidFill>
-                <a:latin typeface="Arial"/>
-                <a:ea typeface="Arial"/>
-                <a:cs typeface="Arial"/>
-              </a:rPr>
-              <a:t>Пределы модели</a:t>
-            </a:r>
-          </a:p>
-        </p:txBody>
-      </p:sp>
-      <p:sp>
-        <p:nvSpPr>
-          <p:cNvPr id="5" name="">
-            <a:extLst xmlns:a="http://schemas.openxmlformats.org/drawingml/2006/main">
-              <a:ext uri="{FF2B5EF4-FFF2-40B4-BE49-F238E27FC236}">
-                <a16:creationId xmlns:a16="http://schemas.microsoft.com/office/drawing/2014/main" id="{1701DA4E-665F-4BD0-906B-AF5CBDCB0A2A}"/>
-              </a:ext>
-            </a:extLst>
-          </p:cNvPr>
-          <p:cNvSpPr>
-            <a:spLocks xmlns:a="http://schemas.openxmlformats.org/drawingml/2006/main" noGrp="1"/>
-          </p:cNvSpPr>
-          <p:nvPr/>
-        </p:nvSpPr>
-        <p:spPr>
-          <a:xfrm xmlns:a="http://schemas.openxmlformats.org/drawingml/2006/main">
-            <a:off x="685800" y="4981575"/>
-            <a:ext cx="10763250" cy="1352550"/>
-          </a:xfrm>
-          <a:prstGeom xmlns:a="http://schemas.openxmlformats.org/drawingml/2006/main" prst="rect">
-            <a:avLst/>
-          </a:prstGeom>
-          <a:noFill xmlns:a="http://schemas.openxmlformats.org/drawingml/2006/main"/>
-          <a:ln xmlns:a="http://schemas.openxmlformats.org/drawingml/2006/main" w="0">
-            <a:noFill/>
-          </a:ln>
-        </p:spPr>
-        <p:txBody>
-          <a:bodyPr xmlns:a="http://schemas.openxmlformats.org/drawingml/2006/main">
-            <a:noAutofit/>
-          </a:bodyPr>
-          <a:lstStyle xmlns:a="http://schemas.openxmlformats.org/drawingml/2006/main"/>
-          <a:p xmlns:a="http://schemas.openxmlformats.org/drawingml/2006/main">
-            <a:pPr>
-              <a:defRPr sz="1875" b="0">
-                <a:solidFill>
-                  <a:srgbClr val="62736B"/>
-                </a:solidFill>
-                <a:latin typeface="Arial"/>
-                <a:ea typeface="Arial"/>
-                <a:cs typeface="Arial"/>
-              </a:defRPr>
-            </a:pPr>
-            <a:r>
-              <a:rPr sz="1875" b="0">
-                <a:solidFill>
-                  <a:srgbClr val="62736B"/>
+              <a:defRPr sz="1575" b="0">
+                <a:solidFill>
+                  <a:srgbClr val="BED2AE"/>
+                </a:solidFill>
+                <a:latin typeface="Arial"/>
+                <a:ea typeface="Arial"/>
+                <a:cs typeface="Arial"/>
+              </a:defRPr>
+            </a:pPr>
+            <a:r>
+              <a:rPr sz="1575" b="0">
+                <a:solidFill>
+                  <a:srgbClr val="BED2AE"/>
                 </a:solidFill>
                 <a:latin typeface="Arial"/>
                 <a:ea typeface="Arial"/>
@@ -5460,48 +5307,25 @@
           </a:p>
           <a:p xmlns:a="http://schemas.openxmlformats.org/drawingml/2006/main">
             <a:pPr>
-              <a:defRPr sz="1875" b="0">
-                <a:solidFill>
-                  <a:srgbClr val="62736B"/>
-                </a:solidFill>
-                <a:latin typeface="Arial"/>
-                <a:ea typeface="Arial"/>
-                <a:cs typeface="Arial"/>
-              </a:defRPr>
-            </a:pPr>
-            <a:r>
-              <a:rPr sz="1875" b="0">
-                <a:solidFill>
-                  <a:srgbClr val="62736B"/>
-                </a:solidFill>
-                <a:latin typeface="Arial"/>
-                <a:ea typeface="Arial"/>
-                <a:cs typeface="Arial"/>
-              </a:rPr>
-              <a:t>Поиск оптимума и случайные события пока не реализованы.</a:t>
-            </a:r>
-          </a:p>
-          <a:p xmlns:a="http://schemas.openxmlformats.org/drawingml/2006/main">
-            <a:pPr>
-              <a:defRPr sz="1875" b="0">
-                <a:solidFill>
-                  <a:srgbClr val="62736B"/>
-                </a:solidFill>
-                <a:latin typeface="Arial"/>
-                <a:ea typeface="Arial"/>
-                <a:cs typeface="Arial"/>
-              </a:defRPr>
-            </a:pPr>
-            <a:r>
-              <a:rPr sz="1875" b="0">
-                <a:solidFill>
-                  <a:srgbClr val="62736B"/>
-                </a:solidFill>
-                <a:latin typeface="Arial"/>
-                <a:ea typeface="Arial"/>
-                <a:cs typeface="Arial"/>
-              </a:rPr>
-              <a:t>AI требует сети. Сервер предназначен для локальной демонстрации.</a:t>
+              <a:defRPr sz="1575" b="0">
+                <a:solidFill>
+                  <a:srgbClr val="BED2AE"/>
+                </a:solidFill>
+                <a:latin typeface="Arial"/>
+                <a:ea typeface="Arial"/>
+                <a:cs typeface="Arial"/>
+              </a:defRPr>
+            </a:pPr>
+            <a:r>
+              <a:rPr sz="1575" b="0">
+                <a:solidFill>
+                  <a:srgbClr val="BED2AE"/>
+                </a:solidFill>
+                <a:latin typeface="Arial"/>
+                <a:ea typeface="Arial"/>
+                <a:cs typeface="Arial"/>
+              </a:rPr>
+              <a:t>AI требует сети. Поиск оптимума и случайные события пока не реализованы.</a:t>
             </a:r>
           </a:p>
         </p:txBody>
@@ -5509,7 +5333,7 @@
     </p:spTree>
     <p:extLst>
       <p:ext uri="{BB962C8B-B14F-4D97-AF65-F5344CB8AC3E}">
-        <p14:creationId xmlns:p14="http://schemas.microsoft.com/office/powerpoint/2010/main" val="344333399"/>
+        <p14:creationId xmlns:p14="http://schemas.microsoft.com/office/powerpoint/2010/main" val="42512744"/>
       </p:ext>
     </p:extLst>
   </p:cSld>

</xml_diff>